<commit_message>
docs: expand product carousel to five slides
</commit_message>
<xml_diff>
--- a/docs/SteelFlow_AI_LinkedIn_Carousel.pptx
+++ b/docs/SteelFlow_AI_LinkedIn_Carousel.pptx
@@ -2,15 +2,17 @@
 <file path=ppt/presentation.xml><?xml version="1.0" encoding="utf-8"?>
 <p:presentation xmlns:p="http://schemas.openxmlformats.org/presentationml/2006/main">
   <p:sldMasterIdLst>
-    <p:sldMasterId xmlns:r="http://schemas.openxmlformats.org/officeDocument/2006/relationships" id="2147483648" r:id="R26e7d0f5fc874eb5"/>
+    <p:sldMasterId xmlns:r="http://schemas.openxmlformats.org/officeDocument/2006/relationships" id="2147483648" r:id="R2166a3e36a254aed"/>
   </p:sldMasterIdLst>
   <p:notesMasterIdLst>
-    <p:notesMasterId xmlns:r="http://schemas.openxmlformats.org/officeDocument/2006/relationships" r:id="R8ef81704d08f48aa"/>
+    <p:notesMasterId xmlns:r="http://schemas.openxmlformats.org/officeDocument/2006/relationships" r:id="Ra63a337227e843ce"/>
   </p:notesMasterIdLst>
   <p:sldIdLst>
-    <p:sldId xmlns:r="http://schemas.openxmlformats.org/officeDocument/2006/relationships" id="256" r:id="R551c72f710124c2f"/>
-    <p:sldId xmlns:r="http://schemas.openxmlformats.org/officeDocument/2006/relationships" id="257" r:id="Rc43c175d650f4efb"/>
-    <p:sldId xmlns:r="http://schemas.openxmlformats.org/officeDocument/2006/relationships" id="258" r:id="Rd2c5971a14484827"/>
+    <p:sldId xmlns:r="http://schemas.openxmlformats.org/officeDocument/2006/relationships" id="256" r:id="Rb84656718e1c4394"/>
+    <p:sldId xmlns:r="http://schemas.openxmlformats.org/officeDocument/2006/relationships" id="257" r:id="R384c7f98936c4175"/>
+    <p:sldId xmlns:r="http://schemas.openxmlformats.org/officeDocument/2006/relationships" id="258" r:id="R912b159c0a094cc1"/>
+    <p:sldId xmlns:r="http://schemas.openxmlformats.org/officeDocument/2006/relationships" id="259" r:id="R69dd126753444f51"/>
+    <p:sldId xmlns:r="http://schemas.openxmlformats.org/officeDocument/2006/relationships" id="260" r:id="R4a649cca10bc4389"/>
   </p:sldIdLst>
   <p:sldSz cx="10287000" cy="12858750"/>
   <p:notesSz cx="6858000" cy="9144000"/>
@@ -534,12 +536,17 @@
           </a:p>
           <a:p xmlns:a="http://schemas.openxmlformats.org/drawingml/2006/main">
             <a:r>
-              <a:t>- artifacts/samples/phase_6_optimization_summaries.json</a:t>
-            </a:r>
-          </a:p>
-          <a:p xmlns:a="http://schemas.openxmlformats.org/drawingml/2006/main">
-            <a:r>
-              <a:t>- docs/images/phase7/scenario-lab.png</a:t>
+              <a:t>- artifacts/samples/phase_7_product_summary.json</a:t>
+            </a:r>
+          </a:p>
+          <a:p xmlns:a="http://schemas.openxmlformats.org/drawingml/2006/main">
+            <a:r>
+              <a:t>- docs/images/phase7/root-cause-explainability.png</a:t>
+            </a:r>
+          </a:p>
+          <a:p xmlns:a="http://schemas.openxmlformats.org/drawingml/2006/main">
+            <a:r>
+              <a:t>- powerbi/README.md</a:t>
             </a:r>
           </a:p>
           <a:p xmlns:a="http://schemas.openxmlformats.org/drawingml/2006/main">
@@ -575,6 +582,176 @@
 </file>
 
 <file path=ppt/notesSlides/notesSlide3.xml><?xml version="1.0" encoding="utf-8"?>
+<p:notes xmlns:p="http://schemas.openxmlformats.org/presentationml/2006/main">
+  <p:cSld>
+    <p:spTree>
+      <p:nvGrpSpPr>
+        <p:cNvPr id="1" name=""/>
+        <p:cNvGrpSpPr/>
+        <p:nvPr/>
+      </p:nvGrpSpPr>
+      <p:grpSpPr>
+        <a:xfrm xmlns:a="http://schemas.openxmlformats.org/drawingml/2006/main"/>
+      </p:grpSpPr>
+      <p:sp>
+        <p:nvSpPr>
+          <p:cNvPr id="2" name="Slide Image Placeholder 1"/>
+          <p:cNvSpPr>
+            <a:spLocks xmlns:a="http://schemas.openxmlformats.org/drawingml/2006/main" noGrp="1"/>
+          </p:cNvSpPr>
+          <p:nvPr>
+            <p:ph type="sldImg" idx="0"/>
+          </p:nvPr>
+        </p:nvSpPr>
+        <p:spPr/>
+      </p:sp>
+      <p:sp>
+        <p:nvSpPr>
+          <p:cNvPr id="3" name="Notes Placeholder 2"/>
+          <p:cNvSpPr>
+            <a:spLocks xmlns:a="http://schemas.openxmlformats.org/drawingml/2006/main" noGrp="1"/>
+          </p:cNvSpPr>
+          <p:nvPr>
+            <p:ph type="body" idx="1"/>
+          </p:nvPr>
+        </p:nvSpPr>
+        <p:spPr/>
+        <p:txBody>
+          <a:bodyPr xmlns:a="http://schemas.openxmlformats.org/drawingml/2006/main"/>
+          <a:lstStyle xmlns:a="http://schemas.openxmlformats.org/drawingml/2006/main"/>
+          <a:p xmlns:a="http://schemas.openxmlformats.org/drawingml/2006/main">
+            <a:r>
+              <a:t>[Sources]</a:t>
+            </a:r>
+          </a:p>
+          <a:p xmlns:a="http://schemas.openxmlformats.org/drawingml/2006/main">
+            <a:r>
+              <a:t>- artifacts/samples/phase_5_modeling_summaries.json</a:t>
+            </a:r>
+          </a:p>
+          <a:p xmlns:a="http://schemas.openxmlformats.org/drawingml/2006/main">
+            <a:r>
+              <a:t>- docs/images/phase7/forecast-risk.png</a:t>
+            </a:r>
+          </a:p>
+          <a:p xmlns:a="http://schemas.openxmlformats.org/drawingml/2006/main">
+            <a:r>
+              <a:t>[/Sources]</a:t>
+            </a:r>
+          </a:p>
+        </p:txBody>
+      </p:sp>
+      <p:sp>
+        <p:nvSpPr>
+          <p:cNvPr id="4" name="Slide Number Placeholder 3"/>
+          <p:cNvSpPr>
+            <a:spLocks xmlns:a="http://schemas.openxmlformats.org/drawingml/2006/main" noGrp="1"/>
+          </p:cNvSpPr>
+          <p:nvPr>
+            <p:ph type="sldNum" idx="5"/>
+          </p:nvPr>
+        </p:nvSpPr>
+        <p:spPr/>
+        <p:txBody>
+          <a:bodyPr xmlns:a="http://schemas.openxmlformats.org/drawingml/2006/main"/>
+          <a:lstStyle xmlns:a="http://schemas.openxmlformats.org/drawingml/2006/main"/>
+          <a:p xmlns:a="http://schemas.openxmlformats.org/drawingml/2006/main"/>
+        </p:txBody>
+      </p:sp>
+    </p:spTree>
+  </p:cSld>
+  <p:clrMapOvr>
+    <a:masterClrMapping xmlns:a="http://schemas.openxmlformats.org/drawingml/2006/main"/>
+  </p:clrMapOvr>
+</p:notes>
+</file>
+
+<file path=ppt/notesSlides/notesSlide4.xml><?xml version="1.0" encoding="utf-8"?>
+<p:notes xmlns:p="http://schemas.openxmlformats.org/presentationml/2006/main">
+  <p:cSld>
+    <p:spTree>
+      <p:nvGrpSpPr>
+        <p:cNvPr id="1" name=""/>
+        <p:cNvGrpSpPr/>
+        <p:nvPr/>
+      </p:nvGrpSpPr>
+      <p:grpSpPr>
+        <a:xfrm xmlns:a="http://schemas.openxmlformats.org/drawingml/2006/main"/>
+      </p:grpSpPr>
+      <p:sp>
+        <p:nvSpPr>
+          <p:cNvPr id="2" name="Slide Image Placeholder 1"/>
+          <p:cNvSpPr>
+            <a:spLocks xmlns:a="http://schemas.openxmlformats.org/drawingml/2006/main" noGrp="1"/>
+          </p:cNvSpPr>
+          <p:nvPr>
+            <p:ph type="sldImg" idx="0"/>
+          </p:nvPr>
+        </p:nvSpPr>
+        <p:spPr/>
+      </p:sp>
+      <p:sp>
+        <p:nvSpPr>
+          <p:cNvPr id="3" name="Notes Placeholder 2"/>
+          <p:cNvSpPr>
+            <a:spLocks xmlns:a="http://schemas.openxmlformats.org/drawingml/2006/main" noGrp="1"/>
+          </p:cNvSpPr>
+          <p:nvPr>
+            <p:ph type="body" idx="1"/>
+          </p:nvPr>
+        </p:nvSpPr>
+        <p:spPr/>
+        <p:txBody>
+          <a:bodyPr xmlns:a="http://schemas.openxmlformats.org/drawingml/2006/main"/>
+          <a:lstStyle xmlns:a="http://schemas.openxmlformats.org/drawingml/2006/main"/>
+          <a:p xmlns:a="http://schemas.openxmlformats.org/drawingml/2006/main">
+            <a:r>
+              <a:t>[Sources]</a:t>
+            </a:r>
+          </a:p>
+          <a:p xmlns:a="http://schemas.openxmlformats.org/drawingml/2006/main">
+            <a:r>
+              <a:t>- artifacts/samples/phase_6_optimization_summaries.json</a:t>
+            </a:r>
+          </a:p>
+          <a:p xmlns:a="http://schemas.openxmlformats.org/drawingml/2006/main">
+            <a:r>
+              <a:t>- docs/images/phase7/scenario-lab.png</a:t>
+            </a:r>
+          </a:p>
+          <a:p xmlns:a="http://schemas.openxmlformats.org/drawingml/2006/main">
+            <a:r>
+              <a:t>[/Sources]</a:t>
+            </a:r>
+          </a:p>
+        </p:txBody>
+      </p:sp>
+      <p:sp>
+        <p:nvSpPr>
+          <p:cNvPr id="4" name="Slide Number Placeholder 3"/>
+          <p:cNvSpPr>
+            <a:spLocks xmlns:a="http://schemas.openxmlformats.org/drawingml/2006/main" noGrp="1"/>
+          </p:cNvSpPr>
+          <p:nvPr>
+            <p:ph type="sldNum" idx="5"/>
+          </p:nvPr>
+        </p:nvSpPr>
+        <p:spPr/>
+        <p:txBody>
+          <a:bodyPr xmlns:a="http://schemas.openxmlformats.org/drawingml/2006/main"/>
+          <a:lstStyle xmlns:a="http://schemas.openxmlformats.org/drawingml/2006/main"/>
+          <a:p xmlns:a="http://schemas.openxmlformats.org/drawingml/2006/main"/>
+        </p:txBody>
+      </p:sp>
+    </p:spTree>
+  </p:cSld>
+  <p:clrMapOvr>
+    <a:masterClrMapping xmlns:a="http://schemas.openxmlformats.org/drawingml/2006/main"/>
+  </p:clrMapOvr>
+</p:notes>
+</file>
+
+<file path=ppt/notesSlides/notesSlide5.xml><?xml version="1.0" encoding="utf-8"?>
 <p:notes xmlns:p="http://schemas.openxmlformats.org/presentationml/2006/main">
   <p:cSld>
     <p:spTree>
@@ -702,7 +879,7 @@
   </p:cSld>
   <p:clrMap bg1="lt1" tx1="dk1" bg2="lt2" tx2="dk2" accent1="accent1" accent2="accent2" accent3="accent3" accent4="accent4" accent5="accent5" accent6="accent6" hlink="hlink" folHlink="folHlink"/>
   <p:sldLayoutIdLst>
-    <p:sldLayoutId xmlns:r="http://schemas.openxmlformats.org/officeDocument/2006/relationships" id="2147483649" r:id="Ra234896f68254edd"/>
+    <p:sldLayoutId xmlns:r="http://schemas.openxmlformats.org/officeDocument/2006/relationships" id="2147483649" r:id="R99ee016e78544bcf"/>
   </p:sldLayoutIdLst>
   <p:txStyles>
     <p:titleStyle>
@@ -1302,7 +1479,7 @@
                 <a:ea typeface="Arial"/>
                 <a:cs typeface="Arial"/>
               </a:rPr>
-              <a:t>O PROBLEMA QUE EU VI</a:t>
+              <a:t>STEELFLOW AI · ANÁLISE DE CENÁRIOS</a:t>
             </a:r>
           </a:p>
         </p:txBody>
@@ -1420,7 +1597,7 @@
                 <a:ea typeface="Arial"/>
                 <a:cs typeface="Arial"/>
               </a:rPr>
-              <a:t>Havia dados.</a:t>
+              <a:t>Dados para comparar</a:t>
             </a:r>
           </a:p>
           <a:p xmlns:a="http://schemas.openxmlformats.org/drawingml/2006/main">
@@ -1444,7 +1621,7 @@
                 <a:ea typeface="Arial"/>
                 <a:cs typeface="Arial"/>
               </a:rPr>
-              <a:t>Faltava testar hipóteses.</a:t>
+              <a:t>decisões.</a:t>
             </a:r>
           </a:p>
         </p:txBody>
@@ -1503,7 +1680,7 @@
                 <a:ea typeface="Arial"/>
                 <a:cs typeface="Arial"/>
               </a:rPr>
-              <a:t>Quando os defeitos apareciam, os parâmetros eram ajustados na tentativa e erro.</a:t>
+              <a:t>Quando um defeito aparece, a plataforma ajuda a trocar tentativa e erro por hipóteses comparáveis.</a:t>
             </a:r>
           </a:p>
         </p:txBody>
@@ -1517,7 +1694,7 @@
           <p:nvPr/>
         </p:nvPicPr>
         <p:blipFill>
-          <a:blip xmlns:r="http://schemas.openxmlformats.org/officeDocument/2006/relationships" xmlns:a="http://schemas.openxmlformats.org/drawingml/2006/main" r:embed="R59877cda60dd45ce"/>
+          <a:blip xmlns:r="http://schemas.openxmlformats.org/officeDocument/2006/relationships" xmlns:a="http://schemas.openxmlformats.org/drawingml/2006/main" r:embed="R906f4f4016474c1f"/>
           <a:srcRect xmlns:a="http://schemas.openxmlformats.org/drawingml/2006/main" l="0" t="6553" r="0" b="6553"/>
           <a:stretch xmlns:a="http://schemas.openxmlformats.org/drawingml/2006/main">
             <a:fillRect l="0" t="0" r="0" b="0"/>
@@ -1648,7 +1825,7 @@
                 <a:ea typeface="Arial"/>
                 <a:cs typeface="Arial"/>
               </a:rPr>
-              <a:t>01/03</a:t>
+              <a:t>01/05</a:t>
             </a:r>
           </a:p>
         </p:txBody>
@@ -1684,10 +1861,10 @@
       </p:grpSpPr>
       <p:sp>
         <p:nvSpPr>
-          <p:cNvPr id="17" name="kicker-7">
-            <a:extLst xmlns:a="http://schemas.openxmlformats.org/drawingml/2006/main">
-              <a:ext uri="{FF2B5EF4-FFF2-40B4-BE49-F238E27FC236}">
-                <a16:creationId xmlns:a16="http://schemas.microsoft.com/office/drawing/2014/main" id="{7DD2BC6F-D214-4CBA-88EC-599B1C28FA7D}"/>
+          <p:cNvPr id="26" name="kicker-8">
+            <a:extLst xmlns:a="http://schemas.openxmlformats.org/drawingml/2006/main">
+              <a:ext uri="{FF2B5EF4-FFF2-40B4-BE49-F238E27FC236}">
+                <a16:creationId xmlns:a16="http://schemas.microsoft.com/office/drawing/2014/main" id="{13323388-F758-47C3-802D-1ACEDC76A4D2}"/>
               </a:ext>
             </a:extLst>
           </p:cNvPr>
@@ -1736,17 +1913,17 @@
                 <a:ea typeface="Arial"/>
                 <a:cs typeface="Arial"/>
               </a:rPr>
-              <a:t>A PROPOSTA</a:t>
-            </a:r>
-          </a:p>
-        </p:txBody>
-      </p:sp>
-      <p:sp>
-        <p:nvSpPr>
-          <p:cNvPr id="2" name="page-7">
-            <a:extLst xmlns:a="http://schemas.openxmlformats.org/drawingml/2006/main">
-              <a:ext uri="{FF2B5EF4-FFF2-40B4-BE49-F238E27FC236}">
-                <a16:creationId xmlns:a16="http://schemas.microsoft.com/office/drawing/2014/main" id="{6A092EF0-99DD-4B9B-AA19-12622A4EDBCC}"/>
+              <a:t>A PLATAFORMA</a:t>
+            </a:r>
+          </a:p>
+        </p:txBody>
+      </p:sp>
+      <p:sp>
+        <p:nvSpPr>
+          <p:cNvPr id="2" name="page-8">
+            <a:extLst xmlns:a="http://schemas.openxmlformats.org/drawingml/2006/main">
+              <a:ext uri="{FF2B5EF4-FFF2-40B4-BE49-F238E27FC236}">
+                <a16:creationId xmlns:a16="http://schemas.microsoft.com/office/drawing/2014/main" id="{085CC0FB-9DA9-4DB1-948A-14D31DFD71C3}"/>
               </a:ext>
             </a:extLst>
           </p:cNvPr>
@@ -1802,10 +1979,10 @@
       </p:sp>
       <p:sp>
         <p:nvSpPr>
-          <p:cNvPr id="3" name="title-7">
-            <a:extLst xmlns:a="http://schemas.openxmlformats.org/drawingml/2006/main">
-              <a:ext uri="{FF2B5EF4-FFF2-40B4-BE49-F238E27FC236}">
-                <a16:creationId xmlns:a16="http://schemas.microsoft.com/office/drawing/2014/main" id="{B63F41E9-DCD1-4F71-9BF9-B13413805947}"/>
+          <p:cNvPr id="3" name="title-8">
+            <a:extLst xmlns:a="http://schemas.openxmlformats.org/drawingml/2006/main">
+              <a:ext uri="{FF2B5EF4-FFF2-40B4-BE49-F238E27FC236}">
+                <a16:creationId xmlns:a16="http://schemas.microsoft.com/office/drawing/2014/main" id="{8EAD528E-F504-44D4-97EC-A4ED4177FC17}"/>
               </a:ext>
             </a:extLst>
           </p:cNvPr>
@@ -1818,6 +1995,65 @@
           <a:xfrm xmlns:a="http://schemas.openxmlformats.org/drawingml/2006/main">
             <a:off x="685800" y="1000125"/>
             <a:ext cx="8915400" cy="1162050"/>
+          </a:xfrm>
+          <a:prstGeom xmlns:a="http://schemas.openxmlformats.org/drawingml/2006/main" prst="rect">
+            <a:avLst/>
+          </a:prstGeom>
+          <a:noFill xmlns:a="http://schemas.openxmlformats.org/drawingml/2006/main"/>
+          <a:ln xmlns:a="http://schemas.openxmlformats.org/drawingml/2006/main" w="0">
+            <a:noFill/>
+            <a:prstDash val="solid"/>
+          </a:ln>
+        </p:spPr>
+        <p:txBody>
+          <a:bodyPr xmlns:a="http://schemas.openxmlformats.org/drawingml/2006/main" anchor="t">
+            <a:normAutofit fontScale="95605"/>
+          </a:bodyPr>
+          <a:lstStyle xmlns:a="http://schemas.openxmlformats.org/drawingml/2006/main"/>
+          <a:p xmlns:a="http://schemas.openxmlformats.org/drawingml/2006/main">
+            <a:pPr algn="l">
+              <a:buNone/>
+              <a:defRPr sz="3750" b="1">
+                <a:solidFill>
+                  <a:srgbClr val="07111C"/>
+                </a:solidFill>
+                <a:latin typeface="Arial"/>
+                <a:ea typeface="Arial"/>
+                <a:cs typeface="Arial"/>
+              </a:defRPr>
+            </a:pPr>
+            <a:r>
+              <a:rPr sz="3750" b="1">
+                <a:solidFill>
+                  <a:srgbClr val="07111C"/>
+                </a:solidFill>
+                <a:latin typeface="Arial"/>
+                <a:ea typeface="Arial"/>
+                <a:cs typeface="Arial"/>
+              </a:rPr>
+              <a:t>Cinco páginas. Uma jornada de decisão.</a:t>
+            </a:r>
+          </a:p>
+        </p:txBody>
+      </p:sp>
+      <p:sp>
+        <p:nvSpPr>
+          <p:cNvPr id="4" name="subtitle-8">
+            <a:extLst xmlns:a="http://schemas.openxmlformats.org/drawingml/2006/main">
+              <a:ext uri="{FF2B5EF4-FFF2-40B4-BE49-F238E27FC236}">
+                <a16:creationId xmlns:a16="http://schemas.microsoft.com/office/drawing/2014/main" id="{8F1FE70D-04EE-4DA5-B441-1A4F36CD241C}"/>
+              </a:ext>
+            </a:extLst>
+          </p:cNvPr>
+          <p:cNvSpPr>
+            <a:spLocks xmlns:a="http://schemas.openxmlformats.org/drawingml/2006/main" noGrp="1"/>
+          </p:cNvSpPr>
+          <p:nvPr/>
+        </p:nvSpPr>
+        <p:spPr>
+          <a:xfrm xmlns:a="http://schemas.openxmlformats.org/drawingml/2006/main">
+            <a:off x="685800" y="2133600"/>
+            <a:ext cx="8915400" cy="704850"/>
           </a:xfrm>
           <a:prstGeom xmlns:a="http://schemas.openxmlformats.org/drawingml/2006/main" prst="rect">
             <a:avLst/>
@@ -1836,65 +2072,6 @@
           <a:p xmlns:a="http://schemas.openxmlformats.org/drawingml/2006/main">
             <a:pPr algn="l">
               <a:buNone/>
-              <a:defRPr sz="3750" b="1">
-                <a:solidFill>
-                  <a:srgbClr val="07111C"/>
-                </a:solidFill>
-                <a:latin typeface="Arial"/>
-                <a:ea typeface="Arial"/>
-                <a:cs typeface="Arial"/>
-              </a:defRPr>
-            </a:pPr>
-            <a:r>
-              <a:rPr sz="3750" b="1">
-                <a:solidFill>
-                  <a:srgbClr val="07111C"/>
-                </a:solidFill>
-                <a:latin typeface="Arial"/>
-                <a:ea typeface="Arial"/>
-                <a:cs typeface="Arial"/>
-              </a:rPr>
-              <a:t>Testar hipóteses antes de ajustar</a:t>
-            </a:r>
-          </a:p>
-        </p:txBody>
-      </p:sp>
-      <p:sp>
-        <p:nvSpPr>
-          <p:cNvPr id="4" name="subtitle-7">
-            <a:extLst xmlns:a="http://schemas.openxmlformats.org/drawingml/2006/main">
-              <a:ext uri="{FF2B5EF4-FFF2-40B4-BE49-F238E27FC236}">
-                <a16:creationId xmlns:a16="http://schemas.microsoft.com/office/drawing/2014/main" id="{301F72D8-C84C-47AE-B5A3-54F74CA295D5}"/>
-              </a:ext>
-            </a:extLst>
-          </p:cNvPr>
-          <p:cNvSpPr>
-            <a:spLocks xmlns:a="http://schemas.openxmlformats.org/drawingml/2006/main" noGrp="1"/>
-          </p:cNvSpPr>
-          <p:nvPr/>
-        </p:nvSpPr>
-        <p:spPr>
-          <a:xfrm xmlns:a="http://schemas.openxmlformats.org/drawingml/2006/main">
-            <a:off x="685800" y="2133600"/>
-            <a:ext cx="8915400" cy="704850"/>
-          </a:xfrm>
-          <a:prstGeom xmlns:a="http://schemas.openxmlformats.org/drawingml/2006/main" prst="rect">
-            <a:avLst/>
-          </a:prstGeom>
-          <a:noFill xmlns:a="http://schemas.openxmlformats.org/drawingml/2006/main"/>
-          <a:ln xmlns:a="http://schemas.openxmlformats.org/drawingml/2006/main" w="0">
-            <a:noFill/>
-            <a:prstDash val="solid"/>
-          </a:ln>
-        </p:spPr>
-        <p:txBody>
-          <a:bodyPr xmlns:a="http://schemas.openxmlformats.org/drawingml/2006/main" anchor="t">
-            <a:normAutofit fontScale="100000"/>
-          </a:bodyPr>
-          <a:lstStyle xmlns:a="http://schemas.openxmlformats.org/drawingml/2006/main"/>
-          <a:p xmlns:a="http://schemas.openxmlformats.org/drawingml/2006/main">
-            <a:pPr algn="l">
-              <a:buNone/>
               <a:defRPr sz="1875" b="0">
                 <a:solidFill>
                   <a:srgbClr val="53606D"/>
@@ -1913,14 +2090,14 @@
                 <a:ea typeface="Arial"/>
                 <a:cs typeface="Arial"/>
               </a:rPr>
-              <a:t>Compare parâmetros e veja probabilidades, faixas e limites.</a:t>
+              <a:t>Veja tendências, influências, riscos, cenários e confiabilidade.</a:t>
             </a:r>
           </a:p>
         </p:txBody>
       </p:sp>
       <p:cxnSp>
         <p:nvCxnSpPr>
-          <p:cNvPr id="81" name="header-rule-7"/>
+          <p:cNvPr id="126" name="header-rule-8"/>
           <p:cNvCxnSpPr/>
           <p:nvPr/>
         </p:nvCxnSpPr>
@@ -1942,22 +2119,22 @@
       </p:cxnSp>
       <p:sp>
         <p:nvSpPr>
-          <p:cNvPr id="6" name="scenario-stat-0">
-            <a:extLst xmlns:a="http://schemas.openxmlformats.org/drawingml/2006/main">
-              <a:ext uri="{FF2B5EF4-FFF2-40B4-BE49-F238E27FC236}">
-                <a16:creationId xmlns:a16="http://schemas.microsoft.com/office/drawing/2014/main" id="{3874855A-F37C-4BE5-91CD-BFB684E4AD1A}"/>
-              </a:ext>
-            </a:extLst>
-          </p:cNvPr>
-          <p:cNvSpPr>
-            <a:spLocks xmlns:a="http://schemas.openxmlformats.org/drawingml/2006/main" noGrp="1"/>
-          </p:cNvSpPr>
-          <p:nvPr/>
-        </p:nvSpPr>
-        <p:spPr>
-          <a:xfrm xmlns:a="http://schemas.openxmlformats.org/drawingml/2006/main">
-            <a:off x="685800" y="3429000"/>
-            <a:ext cx="2381250" cy="685800"/>
+          <p:cNvPr id="6" name="product-index-0">
+            <a:extLst xmlns:a="http://schemas.openxmlformats.org/drawingml/2006/main">
+              <a:ext uri="{FF2B5EF4-FFF2-40B4-BE49-F238E27FC236}">
+                <a16:creationId xmlns:a16="http://schemas.microsoft.com/office/drawing/2014/main" id="{8C5E6F41-3061-44E2-A958-2141A1F641A8}"/>
+              </a:ext>
+            </a:extLst>
+          </p:cNvPr>
+          <p:cNvSpPr>
+            <a:spLocks xmlns:a="http://schemas.openxmlformats.org/drawingml/2006/main" noGrp="1"/>
+          </p:cNvSpPr>
+          <p:nvPr/>
+        </p:nvSpPr>
+        <p:spPr>
+          <a:xfrm xmlns:a="http://schemas.openxmlformats.org/drawingml/2006/main">
+            <a:off x="685800" y="3543300"/>
+            <a:ext cx="628650" cy="438150"/>
           </a:xfrm>
           <a:prstGeom xmlns:a="http://schemas.openxmlformats.org/drawingml/2006/main" prst="rect">
             <a:avLst/>
@@ -1976,7 +2153,7 @@
           <a:p xmlns:a="http://schemas.openxmlformats.org/drawingml/2006/main">
             <a:pPr algn="l">
               <a:buNone/>
-              <a:defRPr sz="3300" b="1">
+              <a:defRPr sz="1650" b="1">
                 <a:solidFill>
                   <a:srgbClr val="3D8DFF"/>
                 </a:solidFill>
@@ -1986,7 +2163,7 @@
               </a:defRPr>
             </a:pPr>
             <a:r>
-              <a:rPr sz="3300" b="1">
+              <a:rPr sz="1650" b="1">
                 <a:solidFill>
                   <a:srgbClr val="3D8DFF"/>
                 </a:solidFill>
@@ -1994,29 +2171,29 @@
                 <a:ea typeface="Arial"/>
                 <a:cs typeface="Arial"/>
               </a:rPr>
-              <a:t>12</a:t>
-            </a:r>
-          </a:p>
-        </p:txBody>
-      </p:sp>
-      <p:sp>
-        <p:nvSpPr>
-          <p:cNvPr id="7" name="scenario-label-0">
-            <a:extLst xmlns:a="http://schemas.openxmlformats.org/drawingml/2006/main">
-              <a:ext uri="{FF2B5EF4-FFF2-40B4-BE49-F238E27FC236}">
-                <a16:creationId xmlns:a16="http://schemas.microsoft.com/office/drawing/2014/main" id="{4B60A1AD-6086-4D18-AA3A-BF02DED97DC9}"/>
-              </a:ext>
-            </a:extLst>
-          </p:cNvPr>
-          <p:cNvSpPr>
-            <a:spLocks xmlns:a="http://schemas.openxmlformats.org/drawingml/2006/main" noGrp="1"/>
-          </p:cNvSpPr>
-          <p:nvPr/>
-        </p:nvSpPr>
-        <p:spPr>
-          <a:xfrm xmlns:a="http://schemas.openxmlformats.org/drawingml/2006/main">
-            <a:off x="685800" y="4171950"/>
-            <a:ext cx="2381250" cy="552450"/>
+              <a:t>01</a:t>
+            </a:r>
+          </a:p>
+        </p:txBody>
+      </p:sp>
+      <p:sp>
+        <p:nvSpPr>
+          <p:cNvPr id="7" name="product-page-0">
+            <a:extLst xmlns:a="http://schemas.openxmlformats.org/drawingml/2006/main">
+              <a:ext uri="{FF2B5EF4-FFF2-40B4-BE49-F238E27FC236}">
+                <a16:creationId xmlns:a16="http://schemas.microsoft.com/office/drawing/2014/main" id="{E620A6BE-FC68-492B-8B95-69CA27A7568F}"/>
+              </a:ext>
+            </a:extLst>
+          </p:cNvPr>
+          <p:cNvSpPr>
+            <a:spLocks xmlns:a="http://schemas.openxmlformats.org/drawingml/2006/main" noGrp="1"/>
+          </p:cNvSpPr>
+          <p:nvPr/>
+        </p:nvSpPr>
+        <p:spPr>
+          <a:xfrm xmlns:a="http://schemas.openxmlformats.org/drawingml/2006/main">
+            <a:off x="1485900" y="3486150"/>
+            <a:ext cx="3429000" cy="552450"/>
           </a:xfrm>
           <a:prstGeom xmlns:a="http://schemas.openxmlformats.org/drawingml/2006/main" prst="rect">
             <a:avLst/>
@@ -2035,47 +2212,69 @@
           <a:p xmlns:a="http://schemas.openxmlformats.org/drawingml/2006/main">
             <a:pPr algn="l">
               <a:buNone/>
-              <a:defRPr sz="1500" b="0">
-                <a:solidFill>
-                  <a:srgbClr val="53606D"/>
-                </a:solidFill>
-                <a:latin typeface="Arial"/>
-                <a:ea typeface="Arial"/>
-                <a:cs typeface="Arial"/>
-              </a:defRPr>
-            </a:pPr>
-            <a:r>
-              <a:rPr sz="1500" b="0">
-                <a:solidFill>
-                  <a:srgbClr val="53606D"/>
-                </a:solidFill>
-                <a:latin typeface="Arial"/>
-                <a:ea typeface="Arial"/>
-                <a:cs typeface="Arial"/>
-              </a:rPr>
-              <a:t>cenários publicados</a:t>
-            </a:r>
-          </a:p>
-        </p:txBody>
-      </p:sp>
-      <p:sp>
-        <p:nvSpPr>
-          <p:cNvPr id="8" name="scenario-stat-1">
-            <a:extLst xmlns:a="http://schemas.openxmlformats.org/drawingml/2006/main">
-              <a:ext uri="{FF2B5EF4-FFF2-40B4-BE49-F238E27FC236}">
-                <a16:creationId xmlns:a16="http://schemas.microsoft.com/office/drawing/2014/main" id="{5D22E322-4953-4C2D-91E9-4402904D1F6F}"/>
-              </a:ext>
-            </a:extLst>
-          </p:cNvPr>
-          <p:cNvSpPr>
-            <a:spLocks xmlns:a="http://schemas.openxmlformats.org/drawingml/2006/main" noGrp="1"/>
-          </p:cNvSpPr>
-          <p:nvPr/>
-        </p:nvSpPr>
-        <p:spPr>
-          <a:xfrm xmlns:a="http://schemas.openxmlformats.org/drawingml/2006/main">
-            <a:off x="3752850" y="3429000"/>
-            <a:ext cx="2381250" cy="685800"/>
+              <a:defRPr sz="1875" b="1">
+                <a:solidFill>
+                  <a:srgbClr val="07111C"/>
+                </a:solidFill>
+                <a:latin typeface="Arial"/>
+                <a:ea typeface="Arial"/>
+                <a:cs typeface="Arial"/>
+              </a:defRPr>
+            </a:pPr>
+            <a:r>
+              <a:rPr sz="1875" b="1">
+                <a:solidFill>
+                  <a:srgbClr val="07111C"/>
+                </a:solidFill>
+                <a:latin typeface="Arial"/>
+                <a:ea typeface="Arial"/>
+                <a:cs typeface="Arial"/>
+              </a:rPr>
+              <a:t>Visão geral</a:t>
+            </a:r>
+          </a:p>
+        </p:txBody>
+      </p:sp>
+      <p:cxnSp>
+        <p:nvCxnSpPr>
+          <p:cNvPr id="129" name="product-rule-0"/>
+          <p:cNvCxnSpPr/>
+          <p:nvPr/>
+        </p:nvCxnSpPr>
+        <p:spPr>
+          <a:xfrm xmlns:a="http://schemas.openxmlformats.org/drawingml/2006/main">
+            <a:off x="1485900" y="4133850"/>
+            <a:ext cx="3429000" cy="0"/>
+          </a:xfrm>
+          <a:prstGeom xmlns:a="http://schemas.openxmlformats.org/drawingml/2006/main" prst="straightConnector1">
+            <a:avLst/>
+          </a:prstGeom>
+          <a:ln xmlns:a="http://schemas.openxmlformats.org/drawingml/2006/main" w="9525">
+            <a:solidFill>
+              <a:srgbClr val="BCC4CC"/>
+            </a:solidFill>
+            <a:prstDash val="solid"/>
+          </a:ln>
+        </p:spPr>
+      </p:cxnSp>
+      <p:sp>
+        <p:nvSpPr>
+          <p:cNvPr id="9" name="product-index-1">
+            <a:extLst xmlns:a="http://schemas.openxmlformats.org/drawingml/2006/main">
+              <a:ext uri="{FF2B5EF4-FFF2-40B4-BE49-F238E27FC236}">
+                <a16:creationId xmlns:a16="http://schemas.microsoft.com/office/drawing/2014/main" id="{EBF830FF-E4DE-4E0C-9072-A52B69F8773E}"/>
+              </a:ext>
+            </a:extLst>
+          </p:cNvPr>
+          <p:cNvSpPr>
+            <a:spLocks xmlns:a="http://schemas.openxmlformats.org/drawingml/2006/main" noGrp="1"/>
+          </p:cNvSpPr>
+          <p:nvPr/>
+        </p:nvSpPr>
+        <p:spPr>
+          <a:xfrm xmlns:a="http://schemas.openxmlformats.org/drawingml/2006/main">
+            <a:off x="685800" y="4610100"/>
+            <a:ext cx="628650" cy="438150"/>
           </a:xfrm>
           <a:prstGeom xmlns:a="http://schemas.openxmlformats.org/drawingml/2006/main" prst="rect">
             <a:avLst/>
@@ -2094,7 +2293,7 @@
           <a:p xmlns:a="http://schemas.openxmlformats.org/drawingml/2006/main">
             <a:pPr algn="l">
               <a:buNone/>
-              <a:defRPr sz="3300" b="1">
+              <a:defRPr sz="1650" b="1">
                 <a:solidFill>
                   <a:srgbClr val="3D8DFF"/>
                 </a:solidFill>
@@ -2104,7 +2303,7 @@
               </a:defRPr>
             </a:pPr>
             <a:r>
-              <a:rPr sz="3300" b="1">
+              <a:rPr sz="1650" b="1">
                 <a:solidFill>
                   <a:srgbClr val="3D8DFF"/>
                 </a:solidFill>
@@ -2112,29 +2311,29 @@
                 <a:ea typeface="Arial"/>
                 <a:cs typeface="Arial"/>
               </a:rPr>
-              <a:t>9</a:t>
-            </a:r>
-          </a:p>
-        </p:txBody>
-      </p:sp>
-      <p:sp>
-        <p:nvSpPr>
-          <p:cNvPr id="9" name="scenario-label-1">
-            <a:extLst xmlns:a="http://schemas.openxmlformats.org/drawingml/2006/main">
-              <a:ext uri="{FF2B5EF4-FFF2-40B4-BE49-F238E27FC236}">
-                <a16:creationId xmlns:a16="http://schemas.microsoft.com/office/drawing/2014/main" id="{E033F261-4F50-4440-B9EC-5106D37A955B}"/>
-              </a:ext>
-            </a:extLst>
-          </p:cNvPr>
-          <p:cNvSpPr>
-            <a:spLocks xmlns:a="http://schemas.openxmlformats.org/drawingml/2006/main" noGrp="1"/>
-          </p:cNvSpPr>
-          <p:nvPr/>
-        </p:nvSpPr>
-        <p:spPr>
-          <a:xfrm xmlns:a="http://schemas.openxmlformats.org/drawingml/2006/main">
-            <a:off x="3752850" y="4171950"/>
-            <a:ext cx="2381250" cy="552450"/>
+              <a:t>02</a:t>
+            </a:r>
+          </a:p>
+        </p:txBody>
+      </p:sp>
+      <p:sp>
+        <p:nvSpPr>
+          <p:cNvPr id="10" name="product-page-1">
+            <a:extLst xmlns:a="http://schemas.openxmlformats.org/drawingml/2006/main">
+              <a:ext uri="{FF2B5EF4-FFF2-40B4-BE49-F238E27FC236}">
+                <a16:creationId xmlns:a16="http://schemas.microsoft.com/office/drawing/2014/main" id="{BC167A51-2493-4275-B03A-235C4AA6B681}"/>
+              </a:ext>
+            </a:extLst>
+          </p:cNvPr>
+          <p:cNvSpPr>
+            <a:spLocks xmlns:a="http://schemas.openxmlformats.org/drawingml/2006/main" noGrp="1"/>
+          </p:cNvSpPr>
+          <p:nvPr/>
+        </p:nvSpPr>
+        <p:spPr>
+          <a:xfrm xmlns:a="http://schemas.openxmlformats.org/drawingml/2006/main">
+            <a:off x="1485900" y="4552950"/>
+            <a:ext cx="3429000" cy="552450"/>
           </a:xfrm>
           <a:prstGeom xmlns:a="http://schemas.openxmlformats.org/drawingml/2006/main" prst="rect">
             <a:avLst/>
@@ -2153,47 +2352,69 @@
           <a:p xmlns:a="http://schemas.openxmlformats.org/drawingml/2006/main">
             <a:pPr algn="l">
               <a:buNone/>
-              <a:defRPr sz="1500" b="0">
-                <a:solidFill>
-                  <a:srgbClr val="53606D"/>
-                </a:solidFill>
-                <a:latin typeface="Arial"/>
-                <a:ea typeface="Arial"/>
-                <a:cs typeface="Arial"/>
-              </a:defRPr>
-            </a:pPr>
-            <a:r>
-              <a:rPr sz="1500" b="0">
-                <a:solidFill>
-                  <a:srgbClr val="53606D"/>
-                </a:solidFill>
-                <a:latin typeface="Arial"/>
-                <a:ea typeface="Arial"/>
-                <a:cs typeface="Arial"/>
-              </a:rPr>
-              <a:t>restrições obrigatórias</a:t>
-            </a:r>
-          </a:p>
-        </p:txBody>
-      </p:sp>
-      <p:sp>
-        <p:nvSpPr>
-          <p:cNvPr id="10" name="scenario-stat-2">
-            <a:extLst xmlns:a="http://schemas.openxmlformats.org/drawingml/2006/main">
-              <a:ext uri="{FF2B5EF4-FFF2-40B4-BE49-F238E27FC236}">
-                <a16:creationId xmlns:a16="http://schemas.microsoft.com/office/drawing/2014/main" id="{7DD40CCC-8CAC-4B1A-A91B-89AD34FD2788}"/>
-              </a:ext>
-            </a:extLst>
-          </p:cNvPr>
-          <p:cNvSpPr>
-            <a:spLocks xmlns:a="http://schemas.openxmlformats.org/drawingml/2006/main" noGrp="1"/>
-          </p:cNvSpPr>
-          <p:nvPr/>
-        </p:nvSpPr>
-        <p:spPr>
-          <a:xfrm xmlns:a="http://schemas.openxmlformats.org/drawingml/2006/main">
-            <a:off x="6819900" y="3429000"/>
-            <a:ext cx="2381250" cy="685800"/>
+              <a:defRPr sz="1875" b="1">
+                <a:solidFill>
+                  <a:srgbClr val="07111C"/>
+                </a:solidFill>
+                <a:latin typeface="Arial"/>
+                <a:ea typeface="Arial"/>
+                <a:cs typeface="Arial"/>
+              </a:defRPr>
+            </a:pPr>
+            <a:r>
+              <a:rPr sz="1875" b="1">
+                <a:solidFill>
+                  <a:srgbClr val="07111C"/>
+                </a:solidFill>
+                <a:latin typeface="Arial"/>
+                <a:ea typeface="Arial"/>
+                <a:cs typeface="Arial"/>
+              </a:rPr>
+              <a:t>O que influenciou</a:t>
+            </a:r>
+          </a:p>
+        </p:txBody>
+      </p:sp>
+      <p:cxnSp>
+        <p:nvCxnSpPr>
+          <p:cNvPr id="132" name="product-rule-1"/>
+          <p:cNvCxnSpPr/>
+          <p:nvPr/>
+        </p:nvCxnSpPr>
+        <p:spPr>
+          <a:xfrm xmlns:a="http://schemas.openxmlformats.org/drawingml/2006/main">
+            <a:off x="1485900" y="5200650"/>
+            <a:ext cx="3429000" cy="0"/>
+          </a:xfrm>
+          <a:prstGeom xmlns:a="http://schemas.openxmlformats.org/drawingml/2006/main" prst="straightConnector1">
+            <a:avLst/>
+          </a:prstGeom>
+          <a:ln xmlns:a="http://schemas.openxmlformats.org/drawingml/2006/main" w="9525">
+            <a:solidFill>
+              <a:srgbClr val="BCC4CC"/>
+            </a:solidFill>
+            <a:prstDash val="solid"/>
+          </a:ln>
+        </p:spPr>
+      </p:cxnSp>
+      <p:sp>
+        <p:nvSpPr>
+          <p:cNvPr id="12" name="product-index-2">
+            <a:extLst xmlns:a="http://schemas.openxmlformats.org/drawingml/2006/main">
+              <a:ext uri="{FF2B5EF4-FFF2-40B4-BE49-F238E27FC236}">
+                <a16:creationId xmlns:a16="http://schemas.microsoft.com/office/drawing/2014/main" id="{32B4761E-026D-488B-9A42-FCE986DB702B}"/>
+              </a:ext>
+            </a:extLst>
+          </p:cNvPr>
+          <p:cNvSpPr>
+            <a:spLocks xmlns:a="http://schemas.openxmlformats.org/drawingml/2006/main" noGrp="1"/>
+          </p:cNvSpPr>
+          <p:nvPr/>
+        </p:nvSpPr>
+        <p:spPr>
+          <a:xfrm xmlns:a="http://schemas.openxmlformats.org/drawingml/2006/main">
+            <a:off x="685800" y="5676900"/>
+            <a:ext cx="628650" cy="438150"/>
           </a:xfrm>
           <a:prstGeom xmlns:a="http://schemas.openxmlformats.org/drawingml/2006/main" prst="rect">
             <a:avLst/>
@@ -2212,47 +2433,47 @@
           <a:p xmlns:a="http://schemas.openxmlformats.org/drawingml/2006/main">
             <a:pPr algn="l">
               <a:buNone/>
-              <a:defRPr sz="3300" b="1">
-                <a:solidFill>
-                  <a:srgbClr val="E55B68"/>
-                </a:solidFill>
-                <a:latin typeface="Arial"/>
-                <a:ea typeface="Arial"/>
-                <a:cs typeface="Arial"/>
-              </a:defRPr>
-            </a:pPr>
-            <a:r>
-              <a:rPr sz="3300" b="1">
-                <a:solidFill>
-                  <a:srgbClr val="E55B68"/>
-                </a:solidFill>
-                <a:latin typeface="Arial"/>
-                <a:ea typeface="Arial"/>
-                <a:cs typeface="Arial"/>
-              </a:rPr>
-              <a:t>3/3</a:t>
-            </a:r>
-          </a:p>
-        </p:txBody>
-      </p:sp>
-      <p:sp>
-        <p:nvSpPr>
-          <p:cNvPr id="11" name="scenario-label-2">
-            <a:extLst xmlns:a="http://schemas.openxmlformats.org/drawingml/2006/main">
-              <a:ext uri="{FF2B5EF4-FFF2-40B4-BE49-F238E27FC236}">
-                <a16:creationId xmlns:a16="http://schemas.microsoft.com/office/drawing/2014/main" id="{A76B89E4-D43B-41CE-8CB1-6E6DA87F4D0B}"/>
-              </a:ext>
-            </a:extLst>
-          </p:cNvPr>
-          <p:cNvSpPr>
-            <a:spLocks xmlns:a="http://schemas.openxmlformats.org/drawingml/2006/main" noGrp="1"/>
-          </p:cNvSpPr>
-          <p:nvPr/>
-        </p:nvSpPr>
-        <p:spPr>
-          <a:xfrm xmlns:a="http://schemas.openxmlformats.org/drawingml/2006/main">
-            <a:off x="6819900" y="4171950"/>
-            <a:ext cx="2381250" cy="552450"/>
+              <a:defRPr sz="1650" b="1">
+                <a:solidFill>
+                  <a:srgbClr val="3D8DFF"/>
+                </a:solidFill>
+                <a:latin typeface="Arial"/>
+                <a:ea typeface="Arial"/>
+                <a:cs typeface="Arial"/>
+              </a:defRPr>
+            </a:pPr>
+            <a:r>
+              <a:rPr sz="1650" b="1">
+                <a:solidFill>
+                  <a:srgbClr val="3D8DFF"/>
+                </a:solidFill>
+                <a:latin typeface="Arial"/>
+                <a:ea typeface="Arial"/>
+                <a:cs typeface="Arial"/>
+              </a:rPr>
+              <a:t>03</a:t>
+            </a:r>
+          </a:p>
+        </p:txBody>
+      </p:sp>
+      <p:sp>
+        <p:nvSpPr>
+          <p:cNvPr id="13" name="product-page-2">
+            <a:extLst xmlns:a="http://schemas.openxmlformats.org/drawingml/2006/main">
+              <a:ext uri="{FF2B5EF4-FFF2-40B4-BE49-F238E27FC236}">
+                <a16:creationId xmlns:a16="http://schemas.microsoft.com/office/drawing/2014/main" id="{DAA49201-0452-461D-8554-51B5EC018777}"/>
+              </a:ext>
+            </a:extLst>
+          </p:cNvPr>
+          <p:cNvSpPr>
+            <a:spLocks xmlns:a="http://schemas.openxmlformats.org/drawingml/2006/main" noGrp="1"/>
+          </p:cNvSpPr>
+          <p:nvPr/>
+        </p:nvSpPr>
+        <p:spPr>
+          <a:xfrm xmlns:a="http://schemas.openxmlformats.org/drawingml/2006/main">
+            <a:off x="1485900" y="5619750"/>
+            <a:ext cx="3429000" cy="552450"/>
           </a:xfrm>
           <a:prstGeom xmlns:a="http://schemas.openxmlformats.org/drawingml/2006/main" prst="rect">
             <a:avLst/>
@@ -2271,98 +2492,413 @@
           <a:p xmlns:a="http://schemas.openxmlformats.org/drawingml/2006/main">
             <a:pPr algn="l">
               <a:buNone/>
-              <a:defRPr sz="1500" b="0">
-                <a:solidFill>
-                  <a:srgbClr val="53606D"/>
-                </a:solidFill>
-                <a:latin typeface="Arial"/>
-                <a:ea typeface="Arial"/>
-                <a:cs typeface="Arial"/>
-              </a:defRPr>
-            </a:pPr>
-            <a:r>
-              <a:rPr sz="1500" b="0">
-                <a:solidFill>
-                  <a:srgbClr val="53606D"/>
-                </a:solidFill>
-                <a:latin typeface="Arial"/>
-                <a:ea typeface="Arial"/>
-                <a:cs typeface="Arial"/>
-              </a:rPr>
-              <a:t>fora do histórico</a:t>
-            </a:r>
-          </a:p>
+              <a:defRPr sz="1875" b="1">
+                <a:solidFill>
+                  <a:srgbClr val="07111C"/>
+                </a:solidFill>
+                <a:latin typeface="Arial"/>
+                <a:ea typeface="Arial"/>
+                <a:cs typeface="Arial"/>
+              </a:defRPr>
+            </a:pPr>
+            <a:r>
+              <a:rPr sz="1875" b="1">
+                <a:solidFill>
+                  <a:srgbClr val="07111C"/>
+                </a:solidFill>
+                <a:latin typeface="Arial"/>
+                <a:ea typeface="Arial"/>
+                <a:cs typeface="Arial"/>
+              </a:rPr>
+              <a:t>Previsão e risco</a:t>
+            </a:r>
+          </a:p>
+        </p:txBody>
+      </p:sp>
+      <p:cxnSp>
+        <p:nvCxnSpPr>
+          <p:cNvPr id="135" name="product-rule-2"/>
+          <p:cNvCxnSpPr/>
+          <p:nvPr/>
+        </p:nvCxnSpPr>
+        <p:spPr>
+          <a:xfrm xmlns:a="http://schemas.openxmlformats.org/drawingml/2006/main">
+            <a:off x="1485900" y="6267450"/>
+            <a:ext cx="3429000" cy="0"/>
+          </a:xfrm>
+          <a:prstGeom xmlns:a="http://schemas.openxmlformats.org/drawingml/2006/main" prst="straightConnector1">
+            <a:avLst/>
+          </a:prstGeom>
+          <a:ln xmlns:a="http://schemas.openxmlformats.org/drawingml/2006/main" w="9525">
+            <a:solidFill>
+              <a:srgbClr val="BCC4CC"/>
+            </a:solidFill>
+            <a:prstDash val="solid"/>
+          </a:ln>
+        </p:spPr>
+      </p:cxnSp>
+      <p:sp>
+        <p:nvSpPr>
+          <p:cNvPr id="15" name="product-index-3">
+            <a:extLst xmlns:a="http://schemas.openxmlformats.org/drawingml/2006/main">
+              <a:ext uri="{FF2B5EF4-FFF2-40B4-BE49-F238E27FC236}">
+                <a16:creationId xmlns:a16="http://schemas.microsoft.com/office/drawing/2014/main" id="{00D96976-D4CC-4D65-B420-80FBC0257C03}"/>
+              </a:ext>
+            </a:extLst>
+          </p:cNvPr>
+          <p:cNvSpPr>
+            <a:spLocks xmlns:a="http://schemas.openxmlformats.org/drawingml/2006/main" noGrp="1"/>
+          </p:cNvSpPr>
+          <p:nvPr/>
+        </p:nvSpPr>
+        <p:spPr>
+          <a:xfrm xmlns:a="http://schemas.openxmlformats.org/drawingml/2006/main">
+            <a:off x="685800" y="6743700"/>
+            <a:ext cx="628650" cy="438150"/>
+          </a:xfrm>
+          <a:prstGeom xmlns:a="http://schemas.openxmlformats.org/drawingml/2006/main" prst="rect">
+            <a:avLst/>
+          </a:prstGeom>
+          <a:noFill xmlns:a="http://schemas.openxmlformats.org/drawingml/2006/main"/>
+          <a:ln xmlns:a="http://schemas.openxmlformats.org/drawingml/2006/main" w="0">
+            <a:noFill/>
+            <a:prstDash val="solid"/>
+          </a:ln>
+        </p:spPr>
+        <p:txBody>
+          <a:bodyPr xmlns:a="http://schemas.openxmlformats.org/drawingml/2006/main" anchor="t">
+            <a:normAutofit fontScale="100000"/>
+          </a:bodyPr>
+          <a:lstStyle xmlns:a="http://schemas.openxmlformats.org/drawingml/2006/main"/>
           <a:p xmlns:a="http://schemas.openxmlformats.org/drawingml/2006/main">
             <a:pPr algn="l">
               <a:buNone/>
-              <a:defRPr sz="1500" b="0">
-                <a:solidFill>
-                  <a:srgbClr val="53606D"/>
-                </a:solidFill>
-                <a:latin typeface="Arial"/>
-                <a:ea typeface="Arial"/>
-                <a:cs typeface="Arial"/>
-              </a:defRPr>
-            </a:pPr>
-            <a:r>
-              <a:rPr sz="1500" b="0">
-                <a:solidFill>
-                  <a:srgbClr val="53606D"/>
-                </a:solidFill>
-                <a:latin typeface="Arial"/>
-                <a:ea typeface="Arial"/>
-                <a:cs typeface="Arial"/>
-              </a:rPr>
-              <a:t>recusadas</a:t>
+              <a:defRPr sz="1650" b="1">
+                <a:solidFill>
+                  <a:srgbClr val="3D8DFF"/>
+                </a:solidFill>
+                <a:latin typeface="Arial"/>
+                <a:ea typeface="Arial"/>
+                <a:cs typeface="Arial"/>
+              </a:defRPr>
+            </a:pPr>
+            <a:r>
+              <a:rPr sz="1650" b="1">
+                <a:solidFill>
+                  <a:srgbClr val="3D8DFF"/>
+                </a:solidFill>
+                <a:latin typeface="Arial"/>
+                <a:ea typeface="Arial"/>
+                <a:cs typeface="Arial"/>
+              </a:rPr>
+              <a:t>04</a:t>
+            </a:r>
+          </a:p>
+        </p:txBody>
+      </p:sp>
+      <p:sp>
+        <p:nvSpPr>
+          <p:cNvPr id="16" name="product-page-3">
+            <a:extLst xmlns:a="http://schemas.openxmlformats.org/drawingml/2006/main">
+              <a:ext uri="{FF2B5EF4-FFF2-40B4-BE49-F238E27FC236}">
+                <a16:creationId xmlns:a16="http://schemas.microsoft.com/office/drawing/2014/main" id="{568E5AE2-EE32-436A-88F0-35FA6D0AFAF0}"/>
+              </a:ext>
+            </a:extLst>
+          </p:cNvPr>
+          <p:cNvSpPr>
+            <a:spLocks xmlns:a="http://schemas.openxmlformats.org/drawingml/2006/main" noGrp="1"/>
+          </p:cNvSpPr>
+          <p:nvPr/>
+        </p:nvSpPr>
+        <p:spPr>
+          <a:xfrm xmlns:a="http://schemas.openxmlformats.org/drawingml/2006/main">
+            <a:off x="1485900" y="6686550"/>
+            <a:ext cx="3429000" cy="552450"/>
+          </a:xfrm>
+          <a:prstGeom xmlns:a="http://schemas.openxmlformats.org/drawingml/2006/main" prst="rect">
+            <a:avLst/>
+          </a:prstGeom>
+          <a:noFill xmlns:a="http://schemas.openxmlformats.org/drawingml/2006/main"/>
+          <a:ln xmlns:a="http://schemas.openxmlformats.org/drawingml/2006/main" w="0">
+            <a:noFill/>
+            <a:prstDash val="solid"/>
+          </a:ln>
+        </p:spPr>
+        <p:txBody>
+          <a:bodyPr xmlns:a="http://schemas.openxmlformats.org/drawingml/2006/main" anchor="t">
+            <a:normAutofit fontScale="100000"/>
+          </a:bodyPr>
+          <a:lstStyle xmlns:a="http://schemas.openxmlformats.org/drawingml/2006/main"/>
+          <a:p xmlns:a="http://schemas.openxmlformats.org/drawingml/2006/main">
+            <a:pPr algn="l">
+              <a:buNone/>
+              <a:defRPr sz="1875" b="1">
+                <a:solidFill>
+                  <a:srgbClr val="07111C"/>
+                </a:solidFill>
+                <a:latin typeface="Arial"/>
+                <a:ea typeface="Arial"/>
+                <a:cs typeface="Arial"/>
+              </a:defRPr>
+            </a:pPr>
+            <a:r>
+              <a:rPr sz="1875" b="1">
+                <a:solidFill>
+                  <a:srgbClr val="07111C"/>
+                </a:solidFill>
+                <a:latin typeface="Arial"/>
+                <a:ea typeface="Arial"/>
+                <a:cs typeface="Arial"/>
+              </a:rPr>
+              <a:t>Teste de cenários</a:t>
+            </a:r>
+          </a:p>
+        </p:txBody>
+      </p:sp>
+      <p:cxnSp>
+        <p:nvCxnSpPr>
+          <p:cNvPr id="138" name="product-rule-3"/>
+          <p:cNvCxnSpPr/>
+          <p:nvPr/>
+        </p:nvCxnSpPr>
+        <p:spPr>
+          <a:xfrm xmlns:a="http://schemas.openxmlformats.org/drawingml/2006/main">
+            <a:off x="1485900" y="7334250"/>
+            <a:ext cx="3429000" cy="0"/>
+          </a:xfrm>
+          <a:prstGeom xmlns:a="http://schemas.openxmlformats.org/drawingml/2006/main" prst="straightConnector1">
+            <a:avLst/>
+          </a:prstGeom>
+          <a:ln xmlns:a="http://schemas.openxmlformats.org/drawingml/2006/main" w="9525">
+            <a:solidFill>
+              <a:srgbClr val="BCC4CC"/>
+            </a:solidFill>
+            <a:prstDash val="solid"/>
+          </a:ln>
+        </p:spPr>
+      </p:cxnSp>
+      <p:sp>
+        <p:nvSpPr>
+          <p:cNvPr id="18" name="product-index-4">
+            <a:extLst xmlns:a="http://schemas.openxmlformats.org/drawingml/2006/main">
+              <a:ext uri="{FF2B5EF4-FFF2-40B4-BE49-F238E27FC236}">
+                <a16:creationId xmlns:a16="http://schemas.microsoft.com/office/drawing/2014/main" id="{24741B3C-62D6-4B77-99E1-12FB6F7AEE3D}"/>
+              </a:ext>
+            </a:extLst>
+          </p:cNvPr>
+          <p:cNvSpPr>
+            <a:spLocks xmlns:a="http://schemas.openxmlformats.org/drawingml/2006/main" noGrp="1"/>
+          </p:cNvSpPr>
+          <p:nvPr/>
+        </p:nvSpPr>
+        <p:spPr>
+          <a:xfrm xmlns:a="http://schemas.openxmlformats.org/drawingml/2006/main">
+            <a:off x="685800" y="7810500"/>
+            <a:ext cx="628650" cy="438150"/>
+          </a:xfrm>
+          <a:prstGeom xmlns:a="http://schemas.openxmlformats.org/drawingml/2006/main" prst="rect">
+            <a:avLst/>
+          </a:prstGeom>
+          <a:noFill xmlns:a="http://schemas.openxmlformats.org/drawingml/2006/main"/>
+          <a:ln xmlns:a="http://schemas.openxmlformats.org/drawingml/2006/main" w="0">
+            <a:noFill/>
+            <a:prstDash val="solid"/>
+          </a:ln>
+        </p:spPr>
+        <p:txBody>
+          <a:bodyPr xmlns:a="http://schemas.openxmlformats.org/drawingml/2006/main" anchor="t">
+            <a:normAutofit fontScale="100000"/>
+          </a:bodyPr>
+          <a:lstStyle xmlns:a="http://schemas.openxmlformats.org/drawingml/2006/main"/>
+          <a:p xmlns:a="http://schemas.openxmlformats.org/drawingml/2006/main">
+            <a:pPr algn="l">
+              <a:buNone/>
+              <a:defRPr sz="1650" b="1">
+                <a:solidFill>
+                  <a:srgbClr val="3D8DFF"/>
+                </a:solidFill>
+                <a:latin typeface="Arial"/>
+                <a:ea typeface="Arial"/>
+                <a:cs typeface="Arial"/>
+              </a:defRPr>
+            </a:pPr>
+            <a:r>
+              <a:rPr sz="1650" b="1">
+                <a:solidFill>
+                  <a:srgbClr val="3D8DFF"/>
+                </a:solidFill>
+                <a:latin typeface="Arial"/>
+                <a:ea typeface="Arial"/>
+                <a:cs typeface="Arial"/>
+              </a:rPr>
+              <a:t>05</a:t>
+            </a:r>
+          </a:p>
+        </p:txBody>
+      </p:sp>
+      <p:sp>
+        <p:nvSpPr>
+          <p:cNvPr id="19" name="product-page-4">
+            <a:extLst xmlns:a="http://schemas.openxmlformats.org/drawingml/2006/main">
+              <a:ext uri="{FF2B5EF4-FFF2-40B4-BE49-F238E27FC236}">
+                <a16:creationId xmlns:a16="http://schemas.microsoft.com/office/drawing/2014/main" id="{F17CF344-F140-4841-BCBF-3E810813091C}"/>
+              </a:ext>
+            </a:extLst>
+          </p:cNvPr>
+          <p:cNvSpPr>
+            <a:spLocks xmlns:a="http://schemas.openxmlformats.org/drawingml/2006/main" noGrp="1"/>
+          </p:cNvSpPr>
+          <p:nvPr/>
+        </p:nvSpPr>
+        <p:spPr>
+          <a:xfrm xmlns:a="http://schemas.openxmlformats.org/drawingml/2006/main">
+            <a:off x="1485900" y="7753350"/>
+            <a:ext cx="3429000" cy="552450"/>
+          </a:xfrm>
+          <a:prstGeom xmlns:a="http://schemas.openxmlformats.org/drawingml/2006/main" prst="rect">
+            <a:avLst/>
+          </a:prstGeom>
+          <a:noFill xmlns:a="http://schemas.openxmlformats.org/drawingml/2006/main"/>
+          <a:ln xmlns:a="http://schemas.openxmlformats.org/drawingml/2006/main" w="0">
+            <a:noFill/>
+            <a:prstDash val="solid"/>
+          </a:ln>
+        </p:spPr>
+        <p:txBody>
+          <a:bodyPr xmlns:a="http://schemas.openxmlformats.org/drawingml/2006/main" anchor="t">
+            <a:normAutofit fontScale="100000"/>
+          </a:bodyPr>
+          <a:lstStyle xmlns:a="http://schemas.openxmlformats.org/drawingml/2006/main"/>
+          <a:p xmlns:a="http://schemas.openxmlformats.org/drawingml/2006/main">
+            <a:pPr algn="l">
+              <a:buNone/>
+              <a:defRPr sz="1875" b="1">
+                <a:solidFill>
+                  <a:srgbClr val="07111C"/>
+                </a:solidFill>
+                <a:latin typeface="Arial"/>
+                <a:ea typeface="Arial"/>
+                <a:cs typeface="Arial"/>
+              </a:defRPr>
+            </a:pPr>
+            <a:r>
+              <a:rPr sz="1875" b="1">
+                <a:solidFill>
+                  <a:srgbClr val="07111C"/>
+                </a:solidFill>
+                <a:latin typeface="Arial"/>
+                <a:ea typeface="Arial"/>
+                <a:cs typeface="Arial"/>
+              </a:rPr>
+              <a:t>Confiabilidade do modelo</a:t>
             </a:r>
           </a:p>
         </p:txBody>
       </p:sp>
       <p:pic>
         <p:nvPicPr>
-          <p:cNvPr id="88" name=""/>
+          <p:cNvPr id="141" name=""/>
           <p:cNvPicPr>
             <a:picLocks xmlns:a="http://schemas.openxmlformats.org/drawingml/2006/main" noChangeAspect="1"/>
           </p:cNvPicPr>
           <p:nvPr/>
         </p:nvPicPr>
         <p:blipFill>
-          <a:blip xmlns:r="http://schemas.openxmlformats.org/officeDocument/2006/relationships" xmlns:a="http://schemas.openxmlformats.org/drawingml/2006/main" r:embed="Ra67721ec89e84179"/>
-          <a:srcRect xmlns:a="http://schemas.openxmlformats.org/drawingml/2006/main" l="0" t="10114" r="0" b="10114"/>
+          <a:blip xmlns:r="http://schemas.openxmlformats.org/officeDocument/2006/relationships" xmlns:a="http://schemas.openxmlformats.org/drawingml/2006/main" r:embed="R4b8c7e6cab9c4c70"/>
+          <a:srcRect xmlns:a="http://schemas.openxmlformats.org/drawingml/2006/main" l="23462" t="0" r="23462" b="0"/>
           <a:stretch xmlns:a="http://schemas.openxmlformats.org/drawingml/2006/main">
             <a:fillRect l="0" t="0" r="0" b="0"/>
           </a:stretch>
         </p:blipFill>
         <p:spPr>
           <a:xfrm xmlns:a="http://schemas.openxmlformats.org/drawingml/2006/main">
-            <a:off x="685800" y="5219700"/>
-            <a:ext cx="8915400" cy="5334000"/>
+            <a:off x="5219700" y="3543300"/>
+            <a:ext cx="4381500" cy="6191250"/>
           </a:xfrm>
           <a:prstGeom xmlns:a="http://schemas.openxmlformats.org/drawingml/2006/main" prst="roundRect">
             <a:avLst>
-              <a:gd name="adj" fmla="val 2143"/>
+              <a:gd name="adj" fmla="val 2609"/>
             </a:avLst>
           </a:prstGeom>
         </p:spPr>
       </p:pic>
       <p:sp>
         <p:nvSpPr>
-          <p:cNvPr id="13" name="scenario-close">
-            <a:extLst xmlns:a="http://schemas.openxmlformats.org/drawingml/2006/main">
-              <a:ext uri="{FF2B5EF4-FFF2-40B4-BE49-F238E27FC236}">
-                <a16:creationId xmlns:a16="http://schemas.microsoft.com/office/drawing/2014/main" id="{77D68B23-F225-4FB9-AD55-5D8FE63700B5}"/>
-              </a:ext>
-            </a:extLst>
-          </p:cNvPr>
-          <p:cNvSpPr>
-            <a:spLocks xmlns:a="http://schemas.openxmlformats.org/drawingml/2006/main" noGrp="1"/>
-          </p:cNvSpPr>
-          <p:nvPr/>
-        </p:nvSpPr>
-        <p:spPr>
-          <a:xfrm xmlns:a="http://schemas.openxmlformats.org/drawingml/2006/main">
-            <a:off x="685800" y="10953750"/>
-            <a:ext cx="8915400" cy="609600"/>
+          <p:cNvPr id="21" name="product-powerbi">
+            <a:extLst xmlns:a="http://schemas.openxmlformats.org/drawingml/2006/main">
+              <a:ext uri="{FF2B5EF4-FFF2-40B4-BE49-F238E27FC236}">
+                <a16:creationId xmlns:a16="http://schemas.microsoft.com/office/drawing/2014/main" id="{801DA8E9-9406-4FF1-A04E-0239F4D8BCDE}"/>
+              </a:ext>
+            </a:extLst>
+          </p:cNvPr>
+          <p:cNvSpPr>
+            <a:spLocks xmlns:a="http://schemas.openxmlformats.org/drawingml/2006/main" noGrp="1"/>
+          </p:cNvSpPr>
+          <p:nvPr/>
+        </p:nvSpPr>
+        <p:spPr>
+          <a:xfrm xmlns:a="http://schemas.openxmlformats.org/drawingml/2006/main">
+            <a:off x="685800" y="9829800"/>
+            <a:ext cx="1714500" cy="342900"/>
+          </a:xfrm>
+          <a:prstGeom xmlns:a="http://schemas.openxmlformats.org/drawingml/2006/main" prst="rect">
+            <a:avLst/>
+          </a:prstGeom>
+          <a:noFill xmlns:a="http://schemas.openxmlformats.org/drawingml/2006/main"/>
+          <a:ln xmlns:a="http://schemas.openxmlformats.org/drawingml/2006/main" w="0">
+            <a:noFill/>
+            <a:prstDash val="solid"/>
+          </a:ln>
+        </p:spPr>
+        <p:txBody>
+          <a:bodyPr xmlns:a="http://schemas.openxmlformats.org/drawingml/2006/main" anchor="t">
+            <a:normAutofit fontScale="61111"/>
+          </a:bodyPr>
+          <a:lstStyle xmlns:a="http://schemas.openxmlformats.org/drawingml/2006/main"/>
+          <a:p xmlns:a="http://schemas.openxmlformats.org/drawingml/2006/main">
+            <a:pPr algn="l">
+              <a:buNone/>
+              <a:defRPr sz="1350" b="1">
+                <a:solidFill>
+                  <a:srgbClr val="3D8DFF"/>
+                </a:solidFill>
+                <a:latin typeface="Arial"/>
+                <a:ea typeface="Arial"/>
+                <a:cs typeface="Arial"/>
+              </a:defRPr>
+            </a:pPr>
+            <a:r>
+              <a:rPr sz="1350" b="1">
+                <a:solidFill>
+                  <a:srgbClr val="3D8DFF"/>
+                </a:solidFill>
+                <a:latin typeface="Arial"/>
+                <a:ea typeface="Arial"/>
+                <a:cs typeface="Arial"/>
+              </a:rPr>
+              <a:t>EXPLORAÇÃO COMPLEMENTAR</a:t>
+            </a:r>
+          </a:p>
+        </p:txBody>
+      </p:sp>
+      <p:sp>
+        <p:nvSpPr>
+          <p:cNvPr id="22" name="product-powerbi-proof">
+            <a:extLst xmlns:a="http://schemas.openxmlformats.org/drawingml/2006/main">
+              <a:ext uri="{FF2B5EF4-FFF2-40B4-BE49-F238E27FC236}">
+                <a16:creationId xmlns:a16="http://schemas.microsoft.com/office/drawing/2014/main" id="{3DFFE398-2209-4AD2-BFFA-486F337BB262}"/>
+              </a:ext>
+            </a:extLst>
+          </p:cNvPr>
+          <p:cNvSpPr>
+            <a:spLocks xmlns:a="http://schemas.openxmlformats.org/drawingml/2006/main" noGrp="1"/>
+          </p:cNvSpPr>
+          <p:nvPr/>
+        </p:nvSpPr>
+        <p:spPr>
+          <a:xfrm xmlns:a="http://schemas.openxmlformats.org/drawingml/2006/main">
+            <a:off x="685800" y="10248900"/>
+            <a:ext cx="8915400" cy="552450"/>
           </a:xfrm>
           <a:prstGeom xmlns:a="http://schemas.openxmlformats.org/drawingml/2006/main" prst="rect">
             <a:avLst/>
@@ -2381,7 +2917,7 @@
           <a:p xmlns:a="http://schemas.openxmlformats.org/drawingml/2006/main">
             <a:pPr algn="l">
               <a:buNone/>
-              <a:defRPr sz="1875" b="1">
+              <a:defRPr sz="2175" b="1">
                 <a:solidFill>
                   <a:srgbClr val="07111C"/>
                 </a:solidFill>
@@ -2391,7 +2927,7 @@
               </a:defRPr>
             </a:pPr>
             <a:r>
-              <a:rPr sz="1875" b="1">
+              <a:rPr sz="2175" b="1">
                 <a:solidFill>
                   <a:srgbClr val="07111C"/>
                 </a:solidFill>
@@ -2399,14 +2935,14 @@
                 <a:ea typeface="Arial"/>
                 <a:cs typeface="Arial"/>
               </a:rPr>
-              <a:t>Probabilidades + P10/P50/P90 + revisão humana.</a:t>
+              <a:t>Power BI com modelo estrela e arquivos verificados</a:t>
             </a:r>
           </a:p>
         </p:txBody>
       </p:sp>
       <p:cxnSp>
         <p:nvCxnSpPr>
-          <p:cNvPr id="90" name="footer-rule-7"/>
+          <p:cNvPr id="144" name="footer-rule-8"/>
           <p:cNvCxnSpPr/>
           <p:nvPr/>
         </p:nvCxnSpPr>
@@ -2428,10 +2964,10 @@
       </p:cxnSp>
       <p:sp>
         <p:nvSpPr>
-          <p:cNvPr id="15" name="footer-7">
-            <a:extLst xmlns:a="http://schemas.openxmlformats.org/drawingml/2006/main">
-              <a:ext uri="{FF2B5EF4-FFF2-40B4-BE49-F238E27FC236}">
-                <a16:creationId xmlns:a16="http://schemas.microsoft.com/office/drawing/2014/main" id="{879FB160-5E7C-4A0A-BE16-8BA8440858BF}"/>
+          <p:cNvPr id="24" name="footer-8">
+            <a:extLst xmlns:a="http://schemas.openxmlformats.org/drawingml/2006/main">
+              <a:ext uri="{FF2B5EF4-FFF2-40B4-BE49-F238E27FC236}">
+                <a16:creationId xmlns:a16="http://schemas.microsoft.com/office/drawing/2014/main" id="{485BCCDE-FD69-4E4E-A7AC-C795AFD6633A}"/>
               </a:ext>
             </a:extLst>
           </p:cNvPr>
@@ -2487,10 +3023,10 @@
       </p:sp>
       <p:sp>
         <p:nvSpPr>
-          <p:cNvPr id="16" name="footer-page-7">
-            <a:extLst xmlns:a="http://schemas.openxmlformats.org/drawingml/2006/main">
-              <a:ext uri="{FF2B5EF4-FFF2-40B4-BE49-F238E27FC236}">
-                <a16:creationId xmlns:a16="http://schemas.microsoft.com/office/drawing/2014/main" id="{6CA91ED8-7E0E-433D-9AFA-55771DA22B52}"/>
+          <p:cNvPr id="25" name="footer-page-8">
+            <a:extLst xmlns:a="http://schemas.openxmlformats.org/drawingml/2006/main">
+              <a:ext uri="{FF2B5EF4-FFF2-40B4-BE49-F238E27FC236}">
+                <a16:creationId xmlns:a16="http://schemas.microsoft.com/office/drawing/2014/main" id="{360922B6-36BE-4A83-BCFF-361D755A7066}"/>
               </a:ext>
             </a:extLst>
           </p:cNvPr>
@@ -2539,7 +3075,7 @@
                 <a:ea typeface="Arial"/>
                 <a:cs typeface="Arial"/>
               </a:rPr>
-              <a:t>2/3</a:t>
+              <a:t>2/5</a:t>
             </a:r>
           </a:p>
         </p:txBody>
@@ -2547,7 +3083,7 @@
     </p:spTree>
     <p:extLst>
       <p:ext uri="{BB962C8B-B14F-4D97-AF65-F5344CB8AC3E}">
-        <p14:creationId xmlns:p14="http://schemas.microsoft.com/office/powerpoint/2010/main" val="679812029"/>
+        <p14:creationId xmlns:p14="http://schemas.microsoft.com/office/powerpoint/2010/main" val="229838652"/>
       </p:ext>
     </p:extLst>
   </p:cSld>
@@ -2575,22 +3111,22 @@
       </p:grpSpPr>
       <p:sp>
         <p:nvSpPr>
-          <p:cNvPr id="10" name="close-kicker">
-            <a:extLst xmlns:a="http://schemas.openxmlformats.org/drawingml/2006/main">
-              <a:ext uri="{FF2B5EF4-FFF2-40B4-BE49-F238E27FC236}">
-                <a16:creationId xmlns:a16="http://schemas.microsoft.com/office/drawing/2014/main" id="{4A29BF44-3BDA-4C78-9CBD-C6046E39C2F2}"/>
-              </a:ext>
-            </a:extLst>
-          </p:cNvPr>
-          <p:cNvSpPr>
-            <a:spLocks xmlns:a="http://schemas.openxmlformats.org/drawingml/2006/main" noGrp="1"/>
-          </p:cNvSpPr>
-          <p:nvPr/>
-        </p:nvSpPr>
-        <p:spPr>
-          <a:xfrm xmlns:a="http://schemas.openxmlformats.org/drawingml/2006/main">
-            <a:off x="685800" y="762000"/>
-            <a:ext cx="8915400" cy="381000"/>
+          <p:cNvPr id="17" name="kicker-6">
+            <a:extLst xmlns:a="http://schemas.openxmlformats.org/drawingml/2006/main">
+              <a:ext uri="{FF2B5EF4-FFF2-40B4-BE49-F238E27FC236}">
+                <a16:creationId xmlns:a16="http://schemas.microsoft.com/office/drawing/2014/main" id="{659F945D-A006-43A3-AB1A-75F5D7E456D3}"/>
+              </a:ext>
+            </a:extLst>
+          </p:cNvPr>
+          <p:cNvSpPr>
+            <a:spLocks xmlns:a="http://schemas.openxmlformats.org/drawingml/2006/main" noGrp="1"/>
+          </p:cNvSpPr>
+          <p:nvPr/>
+        </p:nvSpPr>
+        <p:spPr>
+          <a:xfrm xmlns:a="http://schemas.openxmlformats.org/drawingml/2006/main">
+            <a:off x="685800" y="523875"/>
+            <a:ext cx="7429500" cy="304800"/>
           </a:xfrm>
           <a:prstGeom xmlns:a="http://schemas.openxmlformats.org/drawingml/2006/main" prst="rect">
             <a:avLst/>
@@ -2609,7 +3145,7 @@
           <a:p xmlns:a="http://schemas.openxmlformats.org/drawingml/2006/main">
             <a:pPr algn="l">
               <a:buNone/>
-              <a:defRPr sz="1425" b="1">
+              <a:defRPr sz="1350" b="1">
                 <a:solidFill>
                   <a:srgbClr val="3D8DFF"/>
                 </a:solidFill>
@@ -2619,7 +3155,7 @@
               </a:defRPr>
             </a:pPr>
             <a:r>
-              <a:rPr sz="1425" b="1">
+              <a:rPr sz="1350" b="1">
                 <a:solidFill>
                   <a:srgbClr val="3D8DFF"/>
                 </a:solidFill>
@@ -2627,29 +3163,29 @@
                 <a:ea typeface="Arial"/>
                 <a:cs typeface="Arial"/>
               </a:rPr>
-              <a:t>STEELFLOW AI</a:t>
-            </a:r>
-          </a:p>
-        </p:txBody>
-      </p:sp>
-      <p:sp>
-        <p:nvSpPr>
-          <p:cNvPr id="2" name="close-title">
-            <a:extLst xmlns:a="http://schemas.openxmlformats.org/drawingml/2006/main">
-              <a:ext uri="{FF2B5EF4-FFF2-40B4-BE49-F238E27FC236}">
-                <a16:creationId xmlns:a16="http://schemas.microsoft.com/office/drawing/2014/main" id="{584C9D75-4C20-4B03-ABCF-158C3E284423}"/>
-              </a:ext>
-            </a:extLst>
-          </p:cNvPr>
-          <p:cNvSpPr>
-            <a:spLocks xmlns:a="http://schemas.openxmlformats.org/drawingml/2006/main" noGrp="1"/>
-          </p:cNvSpPr>
-          <p:nvPr/>
-        </p:nvSpPr>
-        <p:spPr>
-          <a:xfrm xmlns:a="http://schemas.openxmlformats.org/drawingml/2006/main">
-            <a:off x="685800" y="1762125"/>
-            <a:ext cx="8915400" cy="2095500"/>
+              <a:t>PREVISÃO E RISCO</a:t>
+            </a:r>
+          </a:p>
+        </p:txBody>
+      </p:sp>
+      <p:sp>
+        <p:nvSpPr>
+          <p:cNvPr id="2" name="page-6">
+            <a:extLst xmlns:a="http://schemas.openxmlformats.org/drawingml/2006/main">
+              <a:ext uri="{FF2B5EF4-FFF2-40B4-BE49-F238E27FC236}">
+                <a16:creationId xmlns:a16="http://schemas.microsoft.com/office/drawing/2014/main" id="{0B509CEE-2A28-444C-B744-1F7E6C3F7E4E}"/>
+              </a:ext>
+            </a:extLst>
+          </p:cNvPr>
+          <p:cNvSpPr>
+            <a:spLocks xmlns:a="http://schemas.openxmlformats.org/drawingml/2006/main" noGrp="1"/>
+          </p:cNvSpPr>
+          <p:nvPr/>
+        </p:nvSpPr>
+        <p:spPr>
+          <a:xfrm xmlns:a="http://schemas.openxmlformats.org/drawingml/2006/main">
+            <a:off x="8705850" y="523875"/>
+            <a:ext cx="895350" cy="304800"/>
           </a:xfrm>
           <a:prstGeom xmlns:a="http://schemas.openxmlformats.org/drawingml/2006/main" prst="rect">
             <a:avLst/>
@@ -2666,73 +3202,49 @@
           </a:bodyPr>
           <a:lstStyle xmlns:a="http://schemas.openxmlformats.org/drawingml/2006/main"/>
           <a:p xmlns:a="http://schemas.openxmlformats.org/drawingml/2006/main">
-            <a:pPr algn="l">
-              <a:buNone/>
-              <a:defRPr sz="4950" b="1">
-                <a:solidFill>
-                  <a:srgbClr val="07111C"/>
-                </a:solidFill>
-                <a:latin typeface="Arial"/>
-                <a:ea typeface="Arial"/>
-                <a:cs typeface="Arial"/>
-              </a:defRPr>
-            </a:pPr>
-            <a:r>
-              <a:rPr sz="4950" b="1">
-                <a:solidFill>
-                  <a:srgbClr val="07111C"/>
-                </a:solidFill>
-                <a:latin typeface="Arial"/>
-                <a:ea typeface="Arial"/>
-                <a:cs typeface="Arial"/>
-              </a:rPr>
-              <a:t>Da tentativa e erro</a:t>
-            </a:r>
-          </a:p>
-          <a:p xmlns:a="http://schemas.openxmlformats.org/drawingml/2006/main">
-            <a:pPr algn="l">
-              <a:buNone/>
-              <a:defRPr sz="4950" b="1">
-                <a:solidFill>
-                  <a:srgbClr val="07111C"/>
-                </a:solidFill>
-                <a:latin typeface="Arial"/>
-                <a:ea typeface="Arial"/>
-                <a:cs typeface="Arial"/>
-              </a:defRPr>
-            </a:pPr>
-            <a:r>
-              <a:rPr sz="4950" b="1">
-                <a:solidFill>
-                  <a:srgbClr val="07111C"/>
-                </a:solidFill>
-                <a:latin typeface="Arial"/>
-                <a:ea typeface="Arial"/>
-                <a:cs typeface="Arial"/>
-              </a:rPr>
-              <a:t>ao teste de hipóteses.</a:t>
-            </a:r>
-          </a:p>
-        </p:txBody>
-      </p:sp>
-      <p:sp>
-        <p:nvSpPr>
-          <p:cNvPr id="3" name="close-body">
-            <a:extLst xmlns:a="http://schemas.openxmlformats.org/drawingml/2006/main">
-              <a:ext uri="{FF2B5EF4-FFF2-40B4-BE49-F238E27FC236}">
-                <a16:creationId xmlns:a16="http://schemas.microsoft.com/office/drawing/2014/main" id="{B4D2B44C-B7F8-4096-840E-D7E4AEEFC94C}"/>
-              </a:ext>
-            </a:extLst>
-          </p:cNvPr>
-          <p:cNvSpPr>
-            <a:spLocks xmlns:a="http://schemas.openxmlformats.org/drawingml/2006/main" noGrp="1"/>
-          </p:cNvSpPr>
-          <p:nvPr/>
-        </p:nvSpPr>
-        <p:spPr>
-          <a:xfrm xmlns:a="http://schemas.openxmlformats.org/drawingml/2006/main">
-            <a:off x="685800" y="4476750"/>
-            <a:ext cx="8191500" cy="1428750"/>
+            <a:pPr algn="r">
+              <a:buNone/>
+              <a:defRPr sz="1350" b="1">
+                <a:solidFill>
+                  <a:srgbClr val="53606D"/>
+                </a:solidFill>
+                <a:latin typeface="Arial"/>
+                <a:ea typeface="Arial"/>
+                <a:cs typeface="Arial"/>
+              </a:defRPr>
+            </a:pPr>
+            <a:r>
+              <a:rPr sz="1350" b="1">
+                <a:solidFill>
+                  <a:srgbClr val="53606D"/>
+                </a:solidFill>
+                <a:latin typeface="Arial"/>
+                <a:ea typeface="Arial"/>
+                <a:cs typeface="Arial"/>
+              </a:rPr>
+              <a:t>03</a:t>
+            </a:r>
+          </a:p>
+        </p:txBody>
+      </p:sp>
+      <p:sp>
+        <p:nvSpPr>
+          <p:cNvPr id="3" name="title-6">
+            <a:extLst xmlns:a="http://schemas.openxmlformats.org/drawingml/2006/main">
+              <a:ext uri="{FF2B5EF4-FFF2-40B4-BE49-F238E27FC236}">
+                <a16:creationId xmlns:a16="http://schemas.microsoft.com/office/drawing/2014/main" id="{5492D9AD-FB96-4C42-8E81-83EF7CDA4A63}"/>
+              </a:ext>
+            </a:extLst>
+          </p:cNvPr>
+          <p:cNvSpPr>
+            <a:spLocks xmlns:a="http://schemas.openxmlformats.org/drawingml/2006/main" noGrp="1"/>
+          </p:cNvSpPr>
+          <p:nvPr/>
+        </p:nvSpPr>
+        <p:spPr>
+          <a:xfrm xmlns:a="http://schemas.openxmlformats.org/drawingml/2006/main">
+            <a:off x="685800" y="1000125"/>
+            <a:ext cx="8915400" cy="1162050"/>
           </a:xfrm>
           <a:prstGeom xmlns:a="http://schemas.openxmlformats.org/drawingml/2006/main" prst="rect">
             <a:avLst/>
@@ -2751,6 +3263,1784 @@
           <a:p xmlns:a="http://schemas.openxmlformats.org/drawingml/2006/main">
             <a:pPr algn="l">
               <a:buNone/>
+              <a:defRPr sz="3750" b="1">
+                <a:solidFill>
+                  <a:srgbClr val="07111C"/>
+                </a:solidFill>
+                <a:latin typeface="Arial"/>
+                <a:ea typeface="Arial"/>
+                <a:cs typeface="Arial"/>
+              </a:defRPr>
+            </a:pPr>
+            <a:r>
+              <a:rPr sz="3750" b="1">
+                <a:solidFill>
+                  <a:srgbClr val="07111C"/>
+                </a:solidFill>
+                <a:latin typeface="Arial"/>
+                <a:ea typeface="Arial"/>
+                <a:cs typeface="Arial"/>
+              </a:rPr>
+              <a:t>A previsão mostra valor, risco e faixa</a:t>
+            </a:r>
+          </a:p>
+        </p:txBody>
+      </p:sp>
+      <p:sp>
+        <p:nvSpPr>
+          <p:cNvPr id="4" name="subtitle-6">
+            <a:extLst xmlns:a="http://schemas.openxmlformats.org/drawingml/2006/main">
+              <a:ext uri="{FF2B5EF4-FFF2-40B4-BE49-F238E27FC236}">
+                <a16:creationId xmlns:a16="http://schemas.microsoft.com/office/drawing/2014/main" id="{B93B64D3-FB90-4719-855E-5414F94AACA1}"/>
+              </a:ext>
+            </a:extLst>
+          </p:cNvPr>
+          <p:cNvSpPr>
+            <a:spLocks xmlns:a="http://schemas.openxmlformats.org/drawingml/2006/main" noGrp="1"/>
+          </p:cNvSpPr>
+          <p:nvPr/>
+        </p:nvSpPr>
+        <p:spPr>
+          <a:xfrm xmlns:a="http://schemas.openxmlformats.org/drawingml/2006/main">
+            <a:off x="685800" y="2133600"/>
+            <a:ext cx="8915400" cy="704850"/>
+          </a:xfrm>
+          <a:prstGeom xmlns:a="http://schemas.openxmlformats.org/drawingml/2006/main" prst="rect">
+            <a:avLst/>
+          </a:prstGeom>
+          <a:noFill xmlns:a="http://schemas.openxmlformats.org/drawingml/2006/main"/>
+          <a:ln xmlns:a="http://schemas.openxmlformats.org/drawingml/2006/main" w="0">
+            <a:noFill/>
+            <a:prstDash val="solid"/>
+          </a:ln>
+        </p:spPr>
+        <p:txBody>
+          <a:bodyPr xmlns:a="http://schemas.openxmlformats.org/drawingml/2006/main" anchor="t">
+            <a:normAutofit fontScale="100000"/>
+          </a:bodyPr>
+          <a:lstStyle xmlns:a="http://schemas.openxmlformats.org/drawingml/2006/main"/>
+          <a:p xmlns:a="http://schemas.openxmlformats.org/drawingml/2006/main">
+            <a:pPr algn="l">
+              <a:buNone/>
+              <a:defRPr sz="1875" b="0">
+                <a:solidFill>
+                  <a:srgbClr val="53606D"/>
+                </a:solidFill>
+                <a:latin typeface="Arial"/>
+                <a:ea typeface="Arial"/>
+                <a:cs typeface="Arial"/>
+              </a:defRPr>
+            </a:pPr>
+            <a:r>
+              <a:rPr sz="1875" b="0">
+                <a:solidFill>
+                  <a:srgbClr val="53606D"/>
+                </a:solidFill>
+                <a:latin typeface="Arial"/>
+                <a:ea typeface="Arial"/>
+                <a:cs typeface="Arial"/>
+              </a:rPr>
+              <a:t>Não entrega apenas um número. Mostra a incerteza.</a:t>
+            </a:r>
+          </a:p>
+        </p:txBody>
+      </p:sp>
+      <p:cxnSp>
+        <p:nvCxnSpPr>
+          <p:cNvPr id="81" name="header-rule-6"/>
+          <p:cNvCxnSpPr/>
+          <p:nvPr/>
+        </p:nvCxnSpPr>
+        <p:spPr>
+          <a:xfrm xmlns:a="http://schemas.openxmlformats.org/drawingml/2006/main">
+            <a:off x="685800" y="2990850"/>
+            <a:ext cx="8915400" cy="0"/>
+          </a:xfrm>
+          <a:prstGeom xmlns:a="http://schemas.openxmlformats.org/drawingml/2006/main" prst="straightConnector1">
+            <a:avLst/>
+          </a:prstGeom>
+          <a:ln xmlns:a="http://schemas.openxmlformats.org/drawingml/2006/main" w="9525">
+            <a:solidFill>
+              <a:srgbClr val="BCC4CC"/>
+            </a:solidFill>
+            <a:prstDash val="solid"/>
+          </a:ln>
+        </p:spPr>
+      </p:cxnSp>
+      <p:sp>
+        <p:nvSpPr>
+          <p:cNvPr id="6" name="coverage-panel">
+            <a:extLst xmlns:a="http://schemas.openxmlformats.org/drawingml/2006/main">
+              <a:ext uri="{FF2B5EF4-FFF2-40B4-BE49-F238E27FC236}">
+                <a16:creationId xmlns:a16="http://schemas.microsoft.com/office/drawing/2014/main" id="{EC299AF2-E080-435B-A00E-BD55179F766D}"/>
+              </a:ext>
+            </a:extLst>
+          </p:cNvPr>
+          <p:cNvSpPr>
+            <a:spLocks xmlns:a="http://schemas.openxmlformats.org/drawingml/2006/main" noGrp="1"/>
+          </p:cNvSpPr>
+          <p:nvPr/>
+        </p:nvSpPr>
+        <p:spPr>
+          <a:xfrm xmlns:a="http://schemas.openxmlformats.org/drawingml/2006/main">
+            <a:off x="685800" y="3543300"/>
+            <a:ext cx="4229100" cy="1809750"/>
+          </a:xfrm>
+          <a:prstGeom xmlns:a="http://schemas.openxmlformats.org/drawingml/2006/main" prst="roundRect">
+            <a:avLst>
+              <a:gd name="adj" fmla="val 6316"/>
+            </a:avLst>
+          </a:prstGeom>
+          <a:solidFill xmlns:a="http://schemas.openxmlformats.org/drawingml/2006/main">
+            <a:srgbClr val="DDF3FC"/>
+          </a:solidFill>
+          <a:ln xmlns:a="http://schemas.openxmlformats.org/drawingml/2006/main" w="0">
+            <a:noFill/>
+            <a:prstDash val="solid"/>
+          </a:ln>
+        </p:spPr>
+      </p:sp>
+      <p:sp>
+        <p:nvSpPr>
+          <p:cNvPr id="7" name="coverage-value">
+            <a:extLst xmlns:a="http://schemas.openxmlformats.org/drawingml/2006/main">
+              <a:ext uri="{FF2B5EF4-FFF2-40B4-BE49-F238E27FC236}">
+                <a16:creationId xmlns:a16="http://schemas.microsoft.com/office/drawing/2014/main" id="{D6CF3F07-787A-47F9-9146-0C2605BF5B61}"/>
+              </a:ext>
+            </a:extLst>
+          </p:cNvPr>
+          <p:cNvSpPr>
+            <a:spLocks xmlns:a="http://schemas.openxmlformats.org/drawingml/2006/main" noGrp="1"/>
+          </p:cNvSpPr>
+          <p:nvPr/>
+        </p:nvSpPr>
+        <p:spPr>
+          <a:xfrm xmlns:a="http://schemas.openxmlformats.org/drawingml/2006/main">
+            <a:off x="971550" y="3943350"/>
+            <a:ext cx="3695700" cy="666750"/>
+          </a:xfrm>
+          <a:prstGeom xmlns:a="http://schemas.openxmlformats.org/drawingml/2006/main" prst="rect">
+            <a:avLst/>
+          </a:prstGeom>
+          <a:noFill xmlns:a="http://schemas.openxmlformats.org/drawingml/2006/main"/>
+          <a:ln xmlns:a="http://schemas.openxmlformats.org/drawingml/2006/main" w="0">
+            <a:noFill/>
+            <a:prstDash val="solid"/>
+          </a:ln>
+        </p:spPr>
+        <p:txBody>
+          <a:bodyPr xmlns:a="http://schemas.openxmlformats.org/drawingml/2006/main" anchor="t">
+            <a:normAutofit fontScale="100000"/>
+          </a:bodyPr>
+          <a:lstStyle xmlns:a="http://schemas.openxmlformats.org/drawingml/2006/main"/>
+          <a:p xmlns:a="http://schemas.openxmlformats.org/drawingml/2006/main">
+            <a:pPr algn="l">
+              <a:buNone/>
+              <a:defRPr sz="3150" b="1">
+                <a:solidFill>
+                  <a:srgbClr val="3D8DFF"/>
+                </a:solidFill>
+                <a:latin typeface="Arial"/>
+                <a:ea typeface="Arial"/>
+                <a:cs typeface="Arial"/>
+              </a:defRPr>
+            </a:pPr>
+            <a:r>
+              <a:rPr sz="3150" b="1">
+                <a:solidFill>
+                  <a:srgbClr val="3D8DFF"/>
+                </a:solidFill>
+                <a:latin typeface="Arial"/>
+                <a:ea typeface="Arial"/>
+                <a:cs typeface="Arial"/>
+              </a:rPr>
+              <a:t>P10–P90</a:t>
+            </a:r>
+          </a:p>
+        </p:txBody>
+      </p:sp>
+      <p:sp>
+        <p:nvSpPr>
+          <p:cNvPr id="8" name="coverage-label">
+            <a:extLst xmlns:a="http://schemas.openxmlformats.org/drawingml/2006/main">
+              <a:ext uri="{FF2B5EF4-FFF2-40B4-BE49-F238E27FC236}">
+                <a16:creationId xmlns:a16="http://schemas.microsoft.com/office/drawing/2014/main" id="{C58CB391-84C5-4855-8331-BB1F00EEE94A}"/>
+              </a:ext>
+            </a:extLst>
+          </p:cNvPr>
+          <p:cNvSpPr>
+            <a:spLocks xmlns:a="http://schemas.openxmlformats.org/drawingml/2006/main" noGrp="1"/>
+          </p:cNvSpPr>
+          <p:nvPr/>
+        </p:nvSpPr>
+        <p:spPr>
+          <a:xfrm xmlns:a="http://schemas.openxmlformats.org/drawingml/2006/main">
+            <a:off x="971550" y="4686300"/>
+            <a:ext cx="3695700" cy="571500"/>
+          </a:xfrm>
+          <a:prstGeom xmlns:a="http://schemas.openxmlformats.org/drawingml/2006/main" prst="rect">
+            <a:avLst/>
+          </a:prstGeom>
+          <a:noFill xmlns:a="http://schemas.openxmlformats.org/drawingml/2006/main"/>
+          <a:ln xmlns:a="http://schemas.openxmlformats.org/drawingml/2006/main" w="0">
+            <a:noFill/>
+            <a:prstDash val="solid"/>
+          </a:ln>
+        </p:spPr>
+        <p:txBody>
+          <a:bodyPr xmlns:a="http://schemas.openxmlformats.org/drawingml/2006/main" anchor="t">
+            <a:normAutofit fontScale="95454"/>
+          </a:bodyPr>
+          <a:lstStyle xmlns:a="http://schemas.openxmlformats.org/drawingml/2006/main"/>
+          <a:p xmlns:a="http://schemas.openxmlformats.org/drawingml/2006/main">
+            <a:pPr algn="l">
+              <a:buNone/>
+              <a:defRPr sz="1650" b="0">
+                <a:solidFill>
+                  <a:srgbClr val="53606D"/>
+                </a:solidFill>
+                <a:latin typeface="Arial"/>
+                <a:ea typeface="Arial"/>
+                <a:cs typeface="Arial"/>
+              </a:defRPr>
+            </a:pPr>
+            <a:r>
+              <a:rPr sz="1650" b="0">
+                <a:solidFill>
+                  <a:srgbClr val="53606D"/>
+                </a:solidFill>
+                <a:latin typeface="Arial"/>
+                <a:ea typeface="Arial"/>
+                <a:cs typeface="Arial"/>
+              </a:rPr>
+              <a:t>faixa provável</a:t>
+            </a:r>
+          </a:p>
+          <a:p xmlns:a="http://schemas.openxmlformats.org/drawingml/2006/main">
+            <a:pPr algn="l">
+              <a:buNone/>
+              <a:defRPr sz="1650" b="0">
+                <a:solidFill>
+                  <a:srgbClr val="53606D"/>
+                </a:solidFill>
+                <a:latin typeface="Arial"/>
+                <a:ea typeface="Arial"/>
+                <a:cs typeface="Arial"/>
+              </a:defRPr>
+            </a:pPr>
+            <a:r>
+              <a:rPr sz="1650" b="0">
+                <a:solidFill>
+                  <a:srgbClr val="53606D"/>
+                </a:solidFill>
+                <a:latin typeface="Arial"/>
+                <a:ea typeface="Arial"/>
+                <a:cs typeface="Arial"/>
+              </a:rPr>
+              <a:t>para cada previsão</a:t>
+            </a:r>
+          </a:p>
+        </p:txBody>
+      </p:sp>
+      <p:sp>
+        <p:nvSpPr>
+          <p:cNvPr id="9" name="calibration-panel">
+            <a:extLst xmlns:a="http://schemas.openxmlformats.org/drawingml/2006/main">
+              <a:ext uri="{FF2B5EF4-FFF2-40B4-BE49-F238E27FC236}">
+                <a16:creationId xmlns:a16="http://schemas.microsoft.com/office/drawing/2014/main" id="{A53F84A9-C583-45A2-A10D-ED2808C11D61}"/>
+              </a:ext>
+            </a:extLst>
+          </p:cNvPr>
+          <p:cNvSpPr>
+            <a:spLocks xmlns:a="http://schemas.openxmlformats.org/drawingml/2006/main" noGrp="1"/>
+          </p:cNvSpPr>
+          <p:nvPr/>
+        </p:nvSpPr>
+        <p:spPr>
+          <a:xfrm xmlns:a="http://schemas.openxmlformats.org/drawingml/2006/main">
+            <a:off x="5372100" y="3543300"/>
+            <a:ext cx="4229100" cy="1809750"/>
+          </a:xfrm>
+          <a:prstGeom xmlns:a="http://schemas.openxmlformats.org/drawingml/2006/main" prst="roundRect">
+            <a:avLst>
+              <a:gd name="adj" fmla="val 6316"/>
+            </a:avLst>
+          </a:prstGeom>
+          <a:solidFill xmlns:a="http://schemas.openxmlformats.org/drawingml/2006/main">
+            <a:srgbClr val="EEF1F4"/>
+          </a:solidFill>
+          <a:ln xmlns:a="http://schemas.openxmlformats.org/drawingml/2006/main" w="0">
+            <a:noFill/>
+            <a:prstDash val="solid"/>
+          </a:ln>
+        </p:spPr>
+      </p:sp>
+      <p:sp>
+        <p:nvSpPr>
+          <p:cNvPr id="10" name="calibration-value">
+            <a:extLst xmlns:a="http://schemas.openxmlformats.org/drawingml/2006/main">
+              <a:ext uri="{FF2B5EF4-FFF2-40B4-BE49-F238E27FC236}">
+                <a16:creationId xmlns:a16="http://schemas.microsoft.com/office/drawing/2014/main" id="{35C904CA-1018-4383-AC1B-D5DF900EC581}"/>
+              </a:ext>
+            </a:extLst>
+          </p:cNvPr>
+          <p:cNvSpPr>
+            <a:spLocks xmlns:a="http://schemas.openxmlformats.org/drawingml/2006/main" noGrp="1"/>
+          </p:cNvSpPr>
+          <p:nvPr/>
+        </p:nvSpPr>
+        <p:spPr>
+          <a:xfrm xmlns:a="http://schemas.openxmlformats.org/drawingml/2006/main">
+            <a:off x="5657850" y="3943350"/>
+            <a:ext cx="3695700" cy="666750"/>
+          </a:xfrm>
+          <a:prstGeom xmlns:a="http://schemas.openxmlformats.org/drawingml/2006/main" prst="rect">
+            <a:avLst/>
+          </a:prstGeom>
+          <a:noFill xmlns:a="http://schemas.openxmlformats.org/drawingml/2006/main"/>
+          <a:ln xmlns:a="http://schemas.openxmlformats.org/drawingml/2006/main" w="0">
+            <a:noFill/>
+            <a:prstDash val="solid"/>
+          </a:ln>
+        </p:spPr>
+        <p:txBody>
+          <a:bodyPr xmlns:a="http://schemas.openxmlformats.org/drawingml/2006/main" anchor="t">
+            <a:normAutofit fontScale="100000"/>
+          </a:bodyPr>
+          <a:lstStyle xmlns:a="http://schemas.openxmlformats.org/drawingml/2006/main"/>
+          <a:p xmlns:a="http://schemas.openxmlformats.org/drawingml/2006/main">
+            <a:pPr algn="l">
+              <a:buNone/>
+              <a:defRPr sz="2700" b="1">
+                <a:solidFill>
+                  <a:srgbClr val="20CDBF"/>
+                </a:solidFill>
+                <a:latin typeface="Arial"/>
+                <a:ea typeface="Arial"/>
+                <a:cs typeface="Arial"/>
+              </a:defRPr>
+            </a:pPr>
+            <a:r>
+              <a:rPr sz="2700" b="1">
+                <a:solidFill>
+                  <a:srgbClr val="20CDBF"/>
+                </a:solidFill>
+                <a:latin typeface="Arial"/>
+                <a:ea typeface="Arial"/>
+                <a:cs typeface="Arial"/>
+              </a:rPr>
+              <a:t>4 modelos</a:t>
+            </a:r>
+          </a:p>
+        </p:txBody>
+      </p:sp>
+      <p:sp>
+        <p:nvSpPr>
+          <p:cNvPr id="11" name="calibration-label">
+            <a:extLst xmlns:a="http://schemas.openxmlformats.org/drawingml/2006/main">
+              <a:ext uri="{FF2B5EF4-FFF2-40B4-BE49-F238E27FC236}">
+                <a16:creationId xmlns:a16="http://schemas.microsoft.com/office/drawing/2014/main" id="{9808A3DB-6589-4E66-82B5-8ACE943759BF}"/>
+              </a:ext>
+            </a:extLst>
+          </p:cNvPr>
+          <p:cNvSpPr>
+            <a:spLocks xmlns:a="http://schemas.openxmlformats.org/drawingml/2006/main" noGrp="1"/>
+          </p:cNvSpPr>
+          <p:nvPr/>
+        </p:nvSpPr>
+        <p:spPr>
+          <a:xfrm xmlns:a="http://schemas.openxmlformats.org/drawingml/2006/main">
+            <a:off x="5657850" y="4686300"/>
+            <a:ext cx="3695700" cy="571500"/>
+          </a:xfrm>
+          <a:prstGeom xmlns:a="http://schemas.openxmlformats.org/drawingml/2006/main" prst="rect">
+            <a:avLst/>
+          </a:prstGeom>
+          <a:noFill xmlns:a="http://schemas.openxmlformats.org/drawingml/2006/main"/>
+          <a:ln xmlns:a="http://schemas.openxmlformats.org/drawingml/2006/main" w="0">
+            <a:noFill/>
+            <a:prstDash val="solid"/>
+          </a:ln>
+        </p:spPr>
+        <p:txBody>
+          <a:bodyPr xmlns:a="http://schemas.openxmlformats.org/drawingml/2006/main" anchor="t">
+            <a:normAutofit fontScale="95454"/>
+          </a:bodyPr>
+          <a:lstStyle xmlns:a="http://schemas.openxmlformats.org/drawingml/2006/main"/>
+          <a:p xmlns:a="http://schemas.openxmlformats.org/drawingml/2006/main">
+            <a:pPr algn="l">
+              <a:buNone/>
+              <a:defRPr sz="1650" b="0">
+                <a:solidFill>
+                  <a:srgbClr val="53606D"/>
+                </a:solidFill>
+                <a:latin typeface="Arial"/>
+                <a:ea typeface="Arial"/>
+                <a:cs typeface="Arial"/>
+              </a:defRPr>
+            </a:pPr>
+            <a:r>
+              <a:rPr sz="1650" b="0">
+                <a:solidFill>
+                  <a:srgbClr val="53606D"/>
+                </a:solidFill>
+                <a:latin typeface="Arial"/>
+                <a:ea typeface="Arial"/>
+                <a:cs typeface="Arial"/>
+              </a:rPr>
+              <a:t>de risco passaram</a:t>
+            </a:r>
+          </a:p>
+          <a:p xmlns:a="http://schemas.openxmlformats.org/drawingml/2006/main">
+            <a:pPr algn="l">
+              <a:buNone/>
+              <a:defRPr sz="1650" b="0">
+                <a:solidFill>
+                  <a:srgbClr val="53606D"/>
+                </a:solidFill>
+                <a:latin typeface="Arial"/>
+                <a:ea typeface="Arial"/>
+                <a:cs typeface="Arial"/>
+              </a:defRPr>
+            </a:pPr>
+            <a:r>
+              <a:rPr sz="1650" b="0">
+                <a:solidFill>
+                  <a:srgbClr val="53606D"/>
+                </a:solidFill>
+                <a:latin typeface="Arial"/>
+                <a:ea typeface="Arial"/>
+                <a:cs typeface="Arial"/>
+              </a:rPr>
+              <a:t>por calibração</a:t>
+            </a:r>
+          </a:p>
+        </p:txBody>
+      </p:sp>
+      <p:pic>
+        <p:nvPicPr>
+          <p:cNvPr id="88" name=""/>
+          <p:cNvPicPr>
+            <a:picLocks xmlns:a="http://schemas.openxmlformats.org/drawingml/2006/main" noChangeAspect="1"/>
+          </p:cNvPicPr>
+          <p:nvPr/>
+        </p:nvPicPr>
+        <p:blipFill>
+          <a:blip xmlns:r="http://schemas.openxmlformats.org/officeDocument/2006/relationships" xmlns:a="http://schemas.openxmlformats.org/drawingml/2006/main" r:embed="Rcf32bc9ce250446f"/>
+          <a:srcRect xmlns:a="http://schemas.openxmlformats.org/drawingml/2006/main" l="0" t="13675" r="0" b="13675"/>
+          <a:stretch xmlns:a="http://schemas.openxmlformats.org/drawingml/2006/main">
+            <a:fillRect l="0" t="0" r="0" b="0"/>
+          </a:stretch>
+        </p:blipFill>
+        <p:spPr>
+          <a:xfrm xmlns:a="http://schemas.openxmlformats.org/drawingml/2006/main">
+            <a:off x="685800" y="5905500"/>
+            <a:ext cx="8915400" cy="4857750"/>
+          </a:xfrm>
+          <a:prstGeom xmlns:a="http://schemas.openxmlformats.org/drawingml/2006/main" prst="roundRect">
+            <a:avLst>
+              <a:gd name="adj" fmla="val 2353"/>
+            </a:avLst>
+          </a:prstGeom>
+        </p:spPr>
+      </p:pic>
+      <p:sp>
+        <p:nvSpPr>
+          <p:cNvPr id="13" name="uncertainty-caption">
+            <a:extLst xmlns:a="http://schemas.openxmlformats.org/drawingml/2006/main">
+              <a:ext uri="{FF2B5EF4-FFF2-40B4-BE49-F238E27FC236}">
+                <a16:creationId xmlns:a16="http://schemas.microsoft.com/office/drawing/2014/main" id="{27BF9B8F-FE17-46E5-A26F-BC14C8E998B6}"/>
+              </a:ext>
+            </a:extLst>
+          </p:cNvPr>
+          <p:cNvSpPr>
+            <a:spLocks xmlns:a="http://schemas.openxmlformats.org/drawingml/2006/main" noGrp="1"/>
+          </p:cNvSpPr>
+          <p:nvPr/>
+        </p:nvSpPr>
+        <p:spPr>
+          <a:xfrm xmlns:a="http://schemas.openxmlformats.org/drawingml/2006/main">
+            <a:off x="685800" y="11125200"/>
+            <a:ext cx="8915400" cy="457200"/>
+          </a:xfrm>
+          <a:prstGeom xmlns:a="http://schemas.openxmlformats.org/drawingml/2006/main" prst="rect">
+            <a:avLst/>
+          </a:prstGeom>
+          <a:noFill xmlns:a="http://schemas.openxmlformats.org/drawingml/2006/main"/>
+          <a:ln xmlns:a="http://schemas.openxmlformats.org/drawingml/2006/main" w="0">
+            <a:noFill/>
+            <a:prstDash val="solid"/>
+          </a:ln>
+        </p:spPr>
+        <p:txBody>
+          <a:bodyPr xmlns:a="http://schemas.openxmlformats.org/drawingml/2006/main" anchor="t">
+            <a:normAutofit fontScale="100000"/>
+          </a:bodyPr>
+          <a:lstStyle xmlns:a="http://schemas.openxmlformats.org/drawingml/2006/main"/>
+          <a:p xmlns:a="http://schemas.openxmlformats.org/drawingml/2006/main">
+            <a:pPr algn="l">
+              <a:buNone/>
+              <a:defRPr sz="2100" b="1">
+                <a:solidFill>
+                  <a:srgbClr val="07111C"/>
+                </a:solidFill>
+                <a:latin typeface="Arial"/>
+                <a:ea typeface="Arial"/>
+                <a:cs typeface="Arial"/>
+              </a:defRPr>
+            </a:pPr>
+            <a:r>
+              <a:rPr sz="2100" b="1">
+                <a:solidFill>
+                  <a:srgbClr val="07111C"/>
+                </a:solidFill>
+                <a:latin typeface="Arial"/>
+                <a:ea typeface="Arial"/>
+                <a:cs typeface="Arial"/>
+              </a:rPr>
+              <a:t>Produtividade, energia, qualidade e parada em contexto.</a:t>
+            </a:r>
+          </a:p>
+        </p:txBody>
+      </p:sp>
+      <p:cxnSp>
+        <p:nvCxnSpPr>
+          <p:cNvPr id="90" name="footer-rule-6"/>
+          <p:cNvCxnSpPr/>
+          <p:nvPr/>
+        </p:nvCxnSpPr>
+        <p:spPr>
+          <a:xfrm xmlns:a="http://schemas.openxmlformats.org/drawingml/2006/main">
+            <a:off x="685800" y="12039600"/>
+            <a:ext cx="8915400" cy="0"/>
+          </a:xfrm>
+          <a:prstGeom xmlns:a="http://schemas.openxmlformats.org/drawingml/2006/main" prst="straightConnector1">
+            <a:avLst/>
+          </a:prstGeom>
+          <a:ln xmlns:a="http://schemas.openxmlformats.org/drawingml/2006/main" w="9525">
+            <a:solidFill>
+              <a:srgbClr val="BCC4CC"/>
+            </a:solidFill>
+            <a:prstDash val="solid"/>
+          </a:ln>
+        </p:spPr>
+      </p:cxnSp>
+      <p:sp>
+        <p:nvSpPr>
+          <p:cNvPr id="15" name="footer-6">
+            <a:extLst xmlns:a="http://schemas.openxmlformats.org/drawingml/2006/main">
+              <a:ext uri="{FF2B5EF4-FFF2-40B4-BE49-F238E27FC236}">
+                <a16:creationId xmlns:a16="http://schemas.microsoft.com/office/drawing/2014/main" id="{4C805FD8-4599-4ADF-B429-241AE7810433}"/>
+              </a:ext>
+            </a:extLst>
+          </p:cNvPr>
+          <p:cNvSpPr>
+            <a:spLocks xmlns:a="http://schemas.openxmlformats.org/drawingml/2006/main" noGrp="1"/>
+          </p:cNvSpPr>
+          <p:nvPr/>
+        </p:nvSpPr>
+        <p:spPr>
+          <a:xfrm xmlns:a="http://schemas.openxmlformats.org/drawingml/2006/main">
+            <a:off x="685800" y="12211050"/>
+            <a:ext cx="7429500" cy="266700"/>
+          </a:xfrm>
+          <a:prstGeom xmlns:a="http://schemas.openxmlformats.org/drawingml/2006/main" prst="rect">
+            <a:avLst/>
+          </a:prstGeom>
+          <a:noFill xmlns:a="http://schemas.openxmlformats.org/drawingml/2006/main"/>
+          <a:ln xmlns:a="http://schemas.openxmlformats.org/drawingml/2006/main" w="0">
+            <a:noFill/>
+            <a:prstDash val="solid"/>
+          </a:ln>
+        </p:spPr>
+        <p:txBody>
+          <a:bodyPr xmlns:a="http://schemas.openxmlformats.org/drawingml/2006/main" anchor="t">
+            <a:normAutofit fontScale="95833"/>
+          </a:bodyPr>
+          <a:lstStyle xmlns:a="http://schemas.openxmlformats.org/drawingml/2006/main"/>
+          <a:p xmlns:a="http://schemas.openxmlformats.org/drawingml/2006/main">
+            <a:pPr algn="l">
+              <a:buNone/>
+              <a:defRPr sz="1200" b="0">
+                <a:solidFill>
+                  <a:srgbClr val="53606D"/>
+                </a:solidFill>
+                <a:latin typeface="Arial"/>
+                <a:ea typeface="Arial"/>
+                <a:cs typeface="Arial"/>
+              </a:defRPr>
+            </a:pPr>
+            <a:r>
+              <a:rPr sz="1200" b="0">
+                <a:solidFill>
+                  <a:srgbClr val="53606D"/>
+                </a:solidFill>
+                <a:latin typeface="Arial"/>
+                <a:ea typeface="Arial"/>
+                <a:cs typeface="Arial"/>
+              </a:rPr>
+              <a:t>100% sintético · sem controle de máquina</a:t>
+            </a:r>
+          </a:p>
+        </p:txBody>
+      </p:sp>
+      <p:sp>
+        <p:nvSpPr>
+          <p:cNvPr id="16" name="footer-page-6">
+            <a:extLst xmlns:a="http://schemas.openxmlformats.org/drawingml/2006/main">
+              <a:ext uri="{FF2B5EF4-FFF2-40B4-BE49-F238E27FC236}">
+                <a16:creationId xmlns:a16="http://schemas.microsoft.com/office/drawing/2014/main" id="{2013CB81-4EEF-4A4F-908A-E38429DD83EC}"/>
+              </a:ext>
+            </a:extLst>
+          </p:cNvPr>
+          <p:cNvSpPr>
+            <a:spLocks xmlns:a="http://schemas.openxmlformats.org/drawingml/2006/main" noGrp="1"/>
+          </p:cNvSpPr>
+          <p:nvPr/>
+        </p:nvSpPr>
+        <p:spPr>
+          <a:xfrm xmlns:a="http://schemas.openxmlformats.org/drawingml/2006/main">
+            <a:off x="8763000" y="12211050"/>
+            <a:ext cx="838200" cy="266700"/>
+          </a:xfrm>
+          <a:prstGeom xmlns:a="http://schemas.openxmlformats.org/drawingml/2006/main" prst="rect">
+            <a:avLst/>
+          </a:prstGeom>
+          <a:noFill xmlns:a="http://schemas.openxmlformats.org/drawingml/2006/main"/>
+          <a:ln xmlns:a="http://schemas.openxmlformats.org/drawingml/2006/main" w="0">
+            <a:noFill/>
+            <a:prstDash val="solid"/>
+          </a:ln>
+        </p:spPr>
+        <p:txBody>
+          <a:bodyPr xmlns:a="http://schemas.openxmlformats.org/drawingml/2006/main" anchor="t">
+            <a:normAutofit fontScale="95833"/>
+          </a:bodyPr>
+          <a:lstStyle xmlns:a="http://schemas.openxmlformats.org/drawingml/2006/main"/>
+          <a:p xmlns:a="http://schemas.openxmlformats.org/drawingml/2006/main">
+            <a:pPr algn="r">
+              <a:buNone/>
+              <a:defRPr sz="1200" b="0">
+                <a:solidFill>
+                  <a:srgbClr val="53606D"/>
+                </a:solidFill>
+                <a:latin typeface="Arial"/>
+                <a:ea typeface="Arial"/>
+                <a:cs typeface="Arial"/>
+              </a:defRPr>
+            </a:pPr>
+            <a:r>
+              <a:rPr sz="1200" b="0">
+                <a:solidFill>
+                  <a:srgbClr val="53606D"/>
+                </a:solidFill>
+                <a:latin typeface="Arial"/>
+                <a:ea typeface="Arial"/>
+                <a:cs typeface="Arial"/>
+              </a:rPr>
+              <a:t>3/5</a:t>
+            </a:r>
+          </a:p>
+        </p:txBody>
+      </p:sp>
+    </p:spTree>
+    <p:extLst>
+      <p:ext uri="{BB962C8B-B14F-4D97-AF65-F5344CB8AC3E}">
+        <p14:creationId xmlns:p14="http://schemas.microsoft.com/office/powerpoint/2010/main" val="998034244"/>
+      </p:ext>
+    </p:extLst>
+  </p:cSld>
+</p:sld>
+</file>
+
+<file path=ppt/slides/slide4.xml><?xml version="1.0" encoding="utf-8"?>
+<p:sld xmlns:p="http://schemas.openxmlformats.org/presentationml/2006/main">
+  <p:cSld>
+    <p:bg>
+      <p:bgPr>
+        <a:solidFill xmlns:a="http://schemas.openxmlformats.org/drawingml/2006/main">
+          <a:srgbClr val="FFFFFF"/>
+        </a:solidFill>
+      </p:bgPr>
+    </p:bg>
+    <p:spTree>
+      <p:nvGrpSpPr>
+        <p:cNvPr id="1" name=""/>
+        <p:cNvGrpSpPr/>
+        <p:nvPr/>
+      </p:nvGrpSpPr>
+      <p:grpSpPr>
+        <a:xfrm xmlns:a="http://schemas.openxmlformats.org/drawingml/2006/main"/>
+      </p:grpSpPr>
+      <p:sp>
+        <p:nvSpPr>
+          <p:cNvPr id="17" name="kicker-7">
+            <a:extLst xmlns:a="http://schemas.openxmlformats.org/drawingml/2006/main">
+              <a:ext uri="{FF2B5EF4-FFF2-40B4-BE49-F238E27FC236}">
+                <a16:creationId xmlns:a16="http://schemas.microsoft.com/office/drawing/2014/main" id="{7DD2BC6F-D214-4CBA-88EC-599B1C28FA7D}"/>
+              </a:ext>
+            </a:extLst>
+          </p:cNvPr>
+          <p:cNvSpPr>
+            <a:spLocks xmlns:a="http://schemas.openxmlformats.org/drawingml/2006/main" noGrp="1"/>
+          </p:cNvSpPr>
+          <p:nvPr/>
+        </p:nvSpPr>
+        <p:spPr>
+          <a:xfrm xmlns:a="http://schemas.openxmlformats.org/drawingml/2006/main">
+            <a:off x="685800" y="523875"/>
+            <a:ext cx="7429500" cy="304800"/>
+          </a:xfrm>
+          <a:prstGeom xmlns:a="http://schemas.openxmlformats.org/drawingml/2006/main" prst="rect">
+            <a:avLst/>
+          </a:prstGeom>
+          <a:noFill xmlns:a="http://schemas.openxmlformats.org/drawingml/2006/main"/>
+          <a:ln xmlns:a="http://schemas.openxmlformats.org/drawingml/2006/main" w="0">
+            <a:noFill/>
+            <a:prstDash val="solid"/>
+          </a:ln>
+        </p:spPr>
+        <p:txBody>
+          <a:bodyPr xmlns:a="http://schemas.openxmlformats.org/drawingml/2006/main" anchor="t">
+            <a:normAutofit fontScale="100000"/>
+          </a:bodyPr>
+          <a:lstStyle xmlns:a="http://schemas.openxmlformats.org/drawingml/2006/main"/>
+          <a:p xmlns:a="http://schemas.openxmlformats.org/drawingml/2006/main">
+            <a:pPr algn="l">
+              <a:buNone/>
+              <a:defRPr sz="1350" b="1">
+                <a:solidFill>
+                  <a:srgbClr val="3D8DFF"/>
+                </a:solidFill>
+                <a:latin typeface="Arial"/>
+                <a:ea typeface="Arial"/>
+                <a:cs typeface="Arial"/>
+              </a:defRPr>
+            </a:pPr>
+            <a:r>
+              <a:rPr sz="1350" b="1">
+                <a:solidFill>
+                  <a:srgbClr val="3D8DFF"/>
+                </a:solidFill>
+                <a:latin typeface="Arial"/>
+                <a:ea typeface="Arial"/>
+                <a:cs typeface="Arial"/>
+              </a:rPr>
+              <a:t>TESTE DE CENÁRIOS</a:t>
+            </a:r>
+          </a:p>
+        </p:txBody>
+      </p:sp>
+      <p:sp>
+        <p:nvSpPr>
+          <p:cNvPr id="2" name="page-7">
+            <a:extLst xmlns:a="http://schemas.openxmlformats.org/drawingml/2006/main">
+              <a:ext uri="{FF2B5EF4-FFF2-40B4-BE49-F238E27FC236}">
+                <a16:creationId xmlns:a16="http://schemas.microsoft.com/office/drawing/2014/main" id="{6A092EF0-99DD-4B9B-AA19-12622A4EDBCC}"/>
+              </a:ext>
+            </a:extLst>
+          </p:cNvPr>
+          <p:cNvSpPr>
+            <a:spLocks xmlns:a="http://schemas.openxmlformats.org/drawingml/2006/main" noGrp="1"/>
+          </p:cNvSpPr>
+          <p:nvPr/>
+        </p:nvSpPr>
+        <p:spPr>
+          <a:xfrm xmlns:a="http://schemas.openxmlformats.org/drawingml/2006/main">
+            <a:off x="8705850" y="523875"/>
+            <a:ext cx="895350" cy="304800"/>
+          </a:xfrm>
+          <a:prstGeom xmlns:a="http://schemas.openxmlformats.org/drawingml/2006/main" prst="rect">
+            <a:avLst/>
+          </a:prstGeom>
+          <a:noFill xmlns:a="http://schemas.openxmlformats.org/drawingml/2006/main"/>
+          <a:ln xmlns:a="http://schemas.openxmlformats.org/drawingml/2006/main" w="0">
+            <a:noFill/>
+            <a:prstDash val="solid"/>
+          </a:ln>
+        </p:spPr>
+        <p:txBody>
+          <a:bodyPr xmlns:a="http://schemas.openxmlformats.org/drawingml/2006/main" anchor="t">
+            <a:normAutofit fontScale="100000"/>
+          </a:bodyPr>
+          <a:lstStyle xmlns:a="http://schemas.openxmlformats.org/drawingml/2006/main"/>
+          <a:p xmlns:a="http://schemas.openxmlformats.org/drawingml/2006/main">
+            <a:pPr algn="r">
+              <a:buNone/>
+              <a:defRPr sz="1350" b="1">
+                <a:solidFill>
+                  <a:srgbClr val="53606D"/>
+                </a:solidFill>
+                <a:latin typeface="Arial"/>
+                <a:ea typeface="Arial"/>
+                <a:cs typeface="Arial"/>
+              </a:defRPr>
+            </a:pPr>
+            <a:r>
+              <a:rPr sz="1350" b="1">
+                <a:solidFill>
+                  <a:srgbClr val="53606D"/>
+                </a:solidFill>
+                <a:latin typeface="Arial"/>
+                <a:ea typeface="Arial"/>
+                <a:cs typeface="Arial"/>
+              </a:rPr>
+              <a:t>04</a:t>
+            </a:r>
+          </a:p>
+        </p:txBody>
+      </p:sp>
+      <p:sp>
+        <p:nvSpPr>
+          <p:cNvPr id="3" name="title-7">
+            <a:extLst xmlns:a="http://schemas.openxmlformats.org/drawingml/2006/main">
+              <a:ext uri="{FF2B5EF4-FFF2-40B4-BE49-F238E27FC236}">
+                <a16:creationId xmlns:a16="http://schemas.microsoft.com/office/drawing/2014/main" id="{B63F41E9-DCD1-4F71-9BF9-B13413805947}"/>
+              </a:ext>
+            </a:extLst>
+          </p:cNvPr>
+          <p:cNvSpPr>
+            <a:spLocks xmlns:a="http://schemas.openxmlformats.org/drawingml/2006/main" noGrp="1"/>
+          </p:cNvSpPr>
+          <p:nvPr/>
+        </p:nvSpPr>
+        <p:spPr>
+          <a:xfrm xmlns:a="http://schemas.openxmlformats.org/drawingml/2006/main">
+            <a:off x="685800" y="1000125"/>
+            <a:ext cx="8915400" cy="1162050"/>
+          </a:xfrm>
+          <a:prstGeom xmlns:a="http://schemas.openxmlformats.org/drawingml/2006/main" prst="rect">
+            <a:avLst/>
+          </a:prstGeom>
+          <a:noFill xmlns:a="http://schemas.openxmlformats.org/drawingml/2006/main"/>
+          <a:ln xmlns:a="http://schemas.openxmlformats.org/drawingml/2006/main" w="0">
+            <a:noFill/>
+            <a:prstDash val="solid"/>
+          </a:ln>
+        </p:spPr>
+        <p:txBody>
+          <a:bodyPr xmlns:a="http://schemas.openxmlformats.org/drawingml/2006/main" anchor="t">
+            <a:normAutofit fontScale="100000"/>
+          </a:bodyPr>
+          <a:lstStyle xmlns:a="http://schemas.openxmlformats.org/drawingml/2006/main"/>
+          <a:p xmlns:a="http://schemas.openxmlformats.org/drawingml/2006/main">
+            <a:pPr algn="l">
+              <a:buNone/>
+              <a:defRPr sz="3750" b="1">
+                <a:solidFill>
+                  <a:srgbClr val="07111C"/>
+                </a:solidFill>
+                <a:latin typeface="Arial"/>
+                <a:ea typeface="Arial"/>
+                <a:cs typeface="Arial"/>
+              </a:defRPr>
+            </a:pPr>
+            <a:r>
+              <a:rPr sz="3750" b="1">
+                <a:solidFill>
+                  <a:srgbClr val="07111C"/>
+                </a:solidFill>
+                <a:latin typeface="Arial"/>
+                <a:ea typeface="Arial"/>
+                <a:cs typeface="Arial"/>
+              </a:rPr>
+              <a:t>Mude parâmetros. Compare cenários.</a:t>
+            </a:r>
+          </a:p>
+        </p:txBody>
+      </p:sp>
+      <p:sp>
+        <p:nvSpPr>
+          <p:cNvPr id="4" name="subtitle-7">
+            <a:extLst xmlns:a="http://schemas.openxmlformats.org/drawingml/2006/main">
+              <a:ext uri="{FF2B5EF4-FFF2-40B4-BE49-F238E27FC236}">
+                <a16:creationId xmlns:a16="http://schemas.microsoft.com/office/drawing/2014/main" id="{301F72D8-C84C-47AE-B5A3-54F74CA295D5}"/>
+              </a:ext>
+            </a:extLst>
+          </p:cNvPr>
+          <p:cNvSpPr>
+            <a:spLocks xmlns:a="http://schemas.openxmlformats.org/drawingml/2006/main" noGrp="1"/>
+          </p:cNvSpPr>
+          <p:nvPr/>
+        </p:nvSpPr>
+        <p:spPr>
+          <a:xfrm xmlns:a="http://schemas.openxmlformats.org/drawingml/2006/main">
+            <a:off x="685800" y="2133600"/>
+            <a:ext cx="8915400" cy="704850"/>
+          </a:xfrm>
+          <a:prstGeom xmlns:a="http://schemas.openxmlformats.org/drawingml/2006/main" prst="rect">
+            <a:avLst/>
+          </a:prstGeom>
+          <a:noFill xmlns:a="http://schemas.openxmlformats.org/drawingml/2006/main"/>
+          <a:ln xmlns:a="http://schemas.openxmlformats.org/drawingml/2006/main" w="0">
+            <a:noFill/>
+            <a:prstDash val="solid"/>
+          </a:ln>
+        </p:spPr>
+        <p:txBody>
+          <a:bodyPr xmlns:a="http://schemas.openxmlformats.org/drawingml/2006/main" anchor="t">
+            <a:normAutofit fontScale="100000"/>
+          </a:bodyPr>
+          <a:lstStyle xmlns:a="http://schemas.openxmlformats.org/drawingml/2006/main"/>
+          <a:p xmlns:a="http://schemas.openxmlformats.org/drawingml/2006/main">
+            <a:pPr algn="l">
+              <a:buNone/>
+              <a:defRPr sz="1875" b="0">
+                <a:solidFill>
+                  <a:srgbClr val="53606D"/>
+                </a:solidFill>
+                <a:latin typeface="Arial"/>
+                <a:ea typeface="Arial"/>
+                <a:cs typeface="Arial"/>
+              </a:defRPr>
+            </a:pPr>
+            <a:r>
+              <a:rPr sz="1875" b="0">
+                <a:solidFill>
+                  <a:srgbClr val="53606D"/>
+                </a:solidFill>
+                <a:latin typeface="Arial"/>
+                <a:ea typeface="Arial"/>
+                <a:cs typeface="Arial"/>
+              </a:rPr>
+              <a:t>A plataforma recalcula resultados e bloqueia hipóteses fora do histórico.</a:t>
+            </a:r>
+          </a:p>
+        </p:txBody>
+      </p:sp>
+      <p:cxnSp>
+        <p:nvCxnSpPr>
+          <p:cNvPr id="81" name="header-rule-7"/>
+          <p:cNvCxnSpPr/>
+          <p:nvPr/>
+        </p:nvCxnSpPr>
+        <p:spPr>
+          <a:xfrm xmlns:a="http://schemas.openxmlformats.org/drawingml/2006/main">
+            <a:off x="685800" y="2990850"/>
+            <a:ext cx="8915400" cy="0"/>
+          </a:xfrm>
+          <a:prstGeom xmlns:a="http://schemas.openxmlformats.org/drawingml/2006/main" prst="straightConnector1">
+            <a:avLst/>
+          </a:prstGeom>
+          <a:ln xmlns:a="http://schemas.openxmlformats.org/drawingml/2006/main" w="9525">
+            <a:solidFill>
+              <a:srgbClr val="BCC4CC"/>
+            </a:solidFill>
+            <a:prstDash val="solid"/>
+          </a:ln>
+        </p:spPr>
+      </p:cxnSp>
+      <p:sp>
+        <p:nvSpPr>
+          <p:cNvPr id="6" name="scenario-stat-0">
+            <a:extLst xmlns:a="http://schemas.openxmlformats.org/drawingml/2006/main">
+              <a:ext uri="{FF2B5EF4-FFF2-40B4-BE49-F238E27FC236}">
+                <a16:creationId xmlns:a16="http://schemas.microsoft.com/office/drawing/2014/main" id="{3874855A-F37C-4BE5-91CD-BFB684E4AD1A}"/>
+              </a:ext>
+            </a:extLst>
+          </p:cNvPr>
+          <p:cNvSpPr>
+            <a:spLocks xmlns:a="http://schemas.openxmlformats.org/drawingml/2006/main" noGrp="1"/>
+          </p:cNvSpPr>
+          <p:nvPr/>
+        </p:nvSpPr>
+        <p:spPr>
+          <a:xfrm xmlns:a="http://schemas.openxmlformats.org/drawingml/2006/main">
+            <a:off x="685800" y="3429000"/>
+            <a:ext cx="2381250" cy="685800"/>
+          </a:xfrm>
+          <a:prstGeom xmlns:a="http://schemas.openxmlformats.org/drawingml/2006/main" prst="rect">
+            <a:avLst/>
+          </a:prstGeom>
+          <a:noFill xmlns:a="http://schemas.openxmlformats.org/drawingml/2006/main"/>
+          <a:ln xmlns:a="http://schemas.openxmlformats.org/drawingml/2006/main" w="0">
+            <a:noFill/>
+            <a:prstDash val="solid"/>
+          </a:ln>
+        </p:spPr>
+        <p:txBody>
+          <a:bodyPr xmlns:a="http://schemas.openxmlformats.org/drawingml/2006/main" anchor="t">
+            <a:normAutofit fontScale="100000"/>
+          </a:bodyPr>
+          <a:lstStyle xmlns:a="http://schemas.openxmlformats.org/drawingml/2006/main"/>
+          <a:p xmlns:a="http://schemas.openxmlformats.org/drawingml/2006/main">
+            <a:pPr algn="l">
+              <a:buNone/>
+              <a:defRPr sz="3300" b="1">
+                <a:solidFill>
+                  <a:srgbClr val="3D8DFF"/>
+                </a:solidFill>
+                <a:latin typeface="Arial"/>
+                <a:ea typeface="Arial"/>
+                <a:cs typeface="Arial"/>
+              </a:defRPr>
+            </a:pPr>
+            <a:r>
+              <a:rPr sz="3300" b="1">
+                <a:solidFill>
+                  <a:srgbClr val="3D8DFF"/>
+                </a:solidFill>
+                <a:latin typeface="Arial"/>
+                <a:ea typeface="Arial"/>
+                <a:cs typeface="Arial"/>
+              </a:rPr>
+              <a:t>12</a:t>
+            </a:r>
+          </a:p>
+        </p:txBody>
+      </p:sp>
+      <p:sp>
+        <p:nvSpPr>
+          <p:cNvPr id="7" name="scenario-label-0">
+            <a:extLst xmlns:a="http://schemas.openxmlformats.org/drawingml/2006/main">
+              <a:ext uri="{FF2B5EF4-FFF2-40B4-BE49-F238E27FC236}">
+                <a16:creationId xmlns:a16="http://schemas.microsoft.com/office/drawing/2014/main" id="{4B60A1AD-6086-4D18-AA3A-BF02DED97DC9}"/>
+              </a:ext>
+            </a:extLst>
+          </p:cNvPr>
+          <p:cNvSpPr>
+            <a:spLocks xmlns:a="http://schemas.openxmlformats.org/drawingml/2006/main" noGrp="1"/>
+          </p:cNvSpPr>
+          <p:nvPr/>
+        </p:nvSpPr>
+        <p:spPr>
+          <a:xfrm xmlns:a="http://schemas.openxmlformats.org/drawingml/2006/main">
+            <a:off x="685800" y="4171950"/>
+            <a:ext cx="2381250" cy="552450"/>
+          </a:xfrm>
+          <a:prstGeom xmlns:a="http://schemas.openxmlformats.org/drawingml/2006/main" prst="rect">
+            <a:avLst/>
+          </a:prstGeom>
+          <a:noFill xmlns:a="http://schemas.openxmlformats.org/drawingml/2006/main"/>
+          <a:ln xmlns:a="http://schemas.openxmlformats.org/drawingml/2006/main" w="0">
+            <a:noFill/>
+            <a:prstDash val="solid"/>
+          </a:ln>
+        </p:spPr>
+        <p:txBody>
+          <a:bodyPr xmlns:a="http://schemas.openxmlformats.org/drawingml/2006/main" anchor="t">
+            <a:normAutofit fontScale="100000"/>
+          </a:bodyPr>
+          <a:lstStyle xmlns:a="http://schemas.openxmlformats.org/drawingml/2006/main"/>
+          <a:p xmlns:a="http://schemas.openxmlformats.org/drawingml/2006/main">
+            <a:pPr algn="l">
+              <a:buNone/>
+              <a:defRPr sz="1500" b="0">
+                <a:solidFill>
+                  <a:srgbClr val="53606D"/>
+                </a:solidFill>
+                <a:latin typeface="Arial"/>
+                <a:ea typeface="Arial"/>
+                <a:cs typeface="Arial"/>
+              </a:defRPr>
+            </a:pPr>
+            <a:r>
+              <a:rPr sz="1500" b="0">
+                <a:solidFill>
+                  <a:srgbClr val="53606D"/>
+                </a:solidFill>
+                <a:latin typeface="Arial"/>
+                <a:ea typeface="Arial"/>
+                <a:cs typeface="Arial"/>
+              </a:rPr>
+              <a:t>cenários publicados</a:t>
+            </a:r>
+          </a:p>
+        </p:txBody>
+      </p:sp>
+      <p:sp>
+        <p:nvSpPr>
+          <p:cNvPr id="8" name="scenario-stat-1">
+            <a:extLst xmlns:a="http://schemas.openxmlformats.org/drawingml/2006/main">
+              <a:ext uri="{FF2B5EF4-FFF2-40B4-BE49-F238E27FC236}">
+                <a16:creationId xmlns:a16="http://schemas.microsoft.com/office/drawing/2014/main" id="{5D22E322-4953-4C2D-91E9-4402904D1F6F}"/>
+              </a:ext>
+            </a:extLst>
+          </p:cNvPr>
+          <p:cNvSpPr>
+            <a:spLocks xmlns:a="http://schemas.openxmlformats.org/drawingml/2006/main" noGrp="1"/>
+          </p:cNvSpPr>
+          <p:nvPr/>
+        </p:nvSpPr>
+        <p:spPr>
+          <a:xfrm xmlns:a="http://schemas.openxmlformats.org/drawingml/2006/main">
+            <a:off x="3752850" y="3429000"/>
+            <a:ext cx="2381250" cy="685800"/>
+          </a:xfrm>
+          <a:prstGeom xmlns:a="http://schemas.openxmlformats.org/drawingml/2006/main" prst="rect">
+            <a:avLst/>
+          </a:prstGeom>
+          <a:noFill xmlns:a="http://schemas.openxmlformats.org/drawingml/2006/main"/>
+          <a:ln xmlns:a="http://schemas.openxmlformats.org/drawingml/2006/main" w="0">
+            <a:noFill/>
+            <a:prstDash val="solid"/>
+          </a:ln>
+        </p:spPr>
+        <p:txBody>
+          <a:bodyPr xmlns:a="http://schemas.openxmlformats.org/drawingml/2006/main" anchor="t">
+            <a:normAutofit fontScale="100000"/>
+          </a:bodyPr>
+          <a:lstStyle xmlns:a="http://schemas.openxmlformats.org/drawingml/2006/main"/>
+          <a:p xmlns:a="http://schemas.openxmlformats.org/drawingml/2006/main">
+            <a:pPr algn="l">
+              <a:buNone/>
+              <a:defRPr sz="3300" b="1">
+                <a:solidFill>
+                  <a:srgbClr val="3D8DFF"/>
+                </a:solidFill>
+                <a:latin typeface="Arial"/>
+                <a:ea typeface="Arial"/>
+                <a:cs typeface="Arial"/>
+              </a:defRPr>
+            </a:pPr>
+            <a:r>
+              <a:rPr sz="3300" b="1">
+                <a:solidFill>
+                  <a:srgbClr val="3D8DFF"/>
+                </a:solidFill>
+                <a:latin typeface="Arial"/>
+                <a:ea typeface="Arial"/>
+                <a:cs typeface="Arial"/>
+              </a:rPr>
+              <a:t>9</a:t>
+            </a:r>
+          </a:p>
+        </p:txBody>
+      </p:sp>
+      <p:sp>
+        <p:nvSpPr>
+          <p:cNvPr id="9" name="scenario-label-1">
+            <a:extLst xmlns:a="http://schemas.openxmlformats.org/drawingml/2006/main">
+              <a:ext uri="{FF2B5EF4-FFF2-40B4-BE49-F238E27FC236}">
+                <a16:creationId xmlns:a16="http://schemas.microsoft.com/office/drawing/2014/main" id="{E033F261-4F50-4440-B9EC-5106D37A955B}"/>
+              </a:ext>
+            </a:extLst>
+          </p:cNvPr>
+          <p:cNvSpPr>
+            <a:spLocks xmlns:a="http://schemas.openxmlformats.org/drawingml/2006/main" noGrp="1"/>
+          </p:cNvSpPr>
+          <p:nvPr/>
+        </p:nvSpPr>
+        <p:spPr>
+          <a:xfrm xmlns:a="http://schemas.openxmlformats.org/drawingml/2006/main">
+            <a:off x="3752850" y="4171950"/>
+            <a:ext cx="2381250" cy="552450"/>
+          </a:xfrm>
+          <a:prstGeom xmlns:a="http://schemas.openxmlformats.org/drawingml/2006/main" prst="rect">
+            <a:avLst/>
+          </a:prstGeom>
+          <a:noFill xmlns:a="http://schemas.openxmlformats.org/drawingml/2006/main"/>
+          <a:ln xmlns:a="http://schemas.openxmlformats.org/drawingml/2006/main" w="0">
+            <a:noFill/>
+            <a:prstDash val="solid"/>
+          </a:ln>
+        </p:spPr>
+        <p:txBody>
+          <a:bodyPr xmlns:a="http://schemas.openxmlformats.org/drawingml/2006/main" anchor="t">
+            <a:normAutofit fontScale="100000"/>
+          </a:bodyPr>
+          <a:lstStyle xmlns:a="http://schemas.openxmlformats.org/drawingml/2006/main"/>
+          <a:p xmlns:a="http://schemas.openxmlformats.org/drawingml/2006/main">
+            <a:pPr algn="l">
+              <a:buNone/>
+              <a:defRPr sz="1500" b="0">
+                <a:solidFill>
+                  <a:srgbClr val="53606D"/>
+                </a:solidFill>
+                <a:latin typeface="Arial"/>
+                <a:ea typeface="Arial"/>
+                <a:cs typeface="Arial"/>
+              </a:defRPr>
+            </a:pPr>
+            <a:r>
+              <a:rPr sz="1500" b="0">
+                <a:solidFill>
+                  <a:srgbClr val="53606D"/>
+                </a:solidFill>
+                <a:latin typeface="Arial"/>
+                <a:ea typeface="Arial"/>
+                <a:cs typeface="Arial"/>
+              </a:rPr>
+              <a:t>restrições obrigatórias</a:t>
+            </a:r>
+          </a:p>
+        </p:txBody>
+      </p:sp>
+      <p:sp>
+        <p:nvSpPr>
+          <p:cNvPr id="10" name="scenario-stat-2">
+            <a:extLst xmlns:a="http://schemas.openxmlformats.org/drawingml/2006/main">
+              <a:ext uri="{FF2B5EF4-FFF2-40B4-BE49-F238E27FC236}">
+                <a16:creationId xmlns:a16="http://schemas.microsoft.com/office/drawing/2014/main" id="{7DD40CCC-8CAC-4B1A-A91B-89AD34FD2788}"/>
+              </a:ext>
+            </a:extLst>
+          </p:cNvPr>
+          <p:cNvSpPr>
+            <a:spLocks xmlns:a="http://schemas.openxmlformats.org/drawingml/2006/main" noGrp="1"/>
+          </p:cNvSpPr>
+          <p:nvPr/>
+        </p:nvSpPr>
+        <p:spPr>
+          <a:xfrm xmlns:a="http://schemas.openxmlformats.org/drawingml/2006/main">
+            <a:off x="6819900" y="3429000"/>
+            <a:ext cx="2381250" cy="685800"/>
+          </a:xfrm>
+          <a:prstGeom xmlns:a="http://schemas.openxmlformats.org/drawingml/2006/main" prst="rect">
+            <a:avLst/>
+          </a:prstGeom>
+          <a:noFill xmlns:a="http://schemas.openxmlformats.org/drawingml/2006/main"/>
+          <a:ln xmlns:a="http://schemas.openxmlformats.org/drawingml/2006/main" w="0">
+            <a:noFill/>
+            <a:prstDash val="solid"/>
+          </a:ln>
+        </p:spPr>
+        <p:txBody>
+          <a:bodyPr xmlns:a="http://schemas.openxmlformats.org/drawingml/2006/main" anchor="t">
+            <a:normAutofit fontScale="100000"/>
+          </a:bodyPr>
+          <a:lstStyle xmlns:a="http://schemas.openxmlformats.org/drawingml/2006/main"/>
+          <a:p xmlns:a="http://schemas.openxmlformats.org/drawingml/2006/main">
+            <a:pPr algn="l">
+              <a:buNone/>
+              <a:defRPr sz="3300" b="1">
+                <a:solidFill>
+                  <a:srgbClr val="E55B68"/>
+                </a:solidFill>
+                <a:latin typeface="Arial"/>
+                <a:ea typeface="Arial"/>
+                <a:cs typeface="Arial"/>
+              </a:defRPr>
+            </a:pPr>
+            <a:r>
+              <a:rPr sz="3300" b="1">
+                <a:solidFill>
+                  <a:srgbClr val="E55B68"/>
+                </a:solidFill>
+                <a:latin typeface="Arial"/>
+                <a:ea typeface="Arial"/>
+                <a:cs typeface="Arial"/>
+              </a:rPr>
+              <a:t>3/3</a:t>
+            </a:r>
+          </a:p>
+        </p:txBody>
+      </p:sp>
+      <p:sp>
+        <p:nvSpPr>
+          <p:cNvPr id="11" name="scenario-label-2">
+            <a:extLst xmlns:a="http://schemas.openxmlformats.org/drawingml/2006/main">
+              <a:ext uri="{FF2B5EF4-FFF2-40B4-BE49-F238E27FC236}">
+                <a16:creationId xmlns:a16="http://schemas.microsoft.com/office/drawing/2014/main" id="{A76B89E4-D43B-41CE-8CB1-6E6DA87F4D0B}"/>
+              </a:ext>
+            </a:extLst>
+          </p:cNvPr>
+          <p:cNvSpPr>
+            <a:spLocks xmlns:a="http://schemas.openxmlformats.org/drawingml/2006/main" noGrp="1"/>
+          </p:cNvSpPr>
+          <p:nvPr/>
+        </p:nvSpPr>
+        <p:spPr>
+          <a:xfrm xmlns:a="http://schemas.openxmlformats.org/drawingml/2006/main">
+            <a:off x="6819900" y="4171950"/>
+            <a:ext cx="2381250" cy="552450"/>
+          </a:xfrm>
+          <a:prstGeom xmlns:a="http://schemas.openxmlformats.org/drawingml/2006/main" prst="rect">
+            <a:avLst/>
+          </a:prstGeom>
+          <a:noFill xmlns:a="http://schemas.openxmlformats.org/drawingml/2006/main"/>
+          <a:ln xmlns:a="http://schemas.openxmlformats.org/drawingml/2006/main" w="0">
+            <a:noFill/>
+            <a:prstDash val="solid"/>
+          </a:ln>
+        </p:spPr>
+        <p:txBody>
+          <a:bodyPr xmlns:a="http://schemas.openxmlformats.org/drawingml/2006/main" anchor="t">
+            <a:normAutofit fontScale="100000"/>
+          </a:bodyPr>
+          <a:lstStyle xmlns:a="http://schemas.openxmlformats.org/drawingml/2006/main"/>
+          <a:p xmlns:a="http://schemas.openxmlformats.org/drawingml/2006/main">
+            <a:pPr algn="l">
+              <a:buNone/>
+              <a:defRPr sz="1500" b="0">
+                <a:solidFill>
+                  <a:srgbClr val="53606D"/>
+                </a:solidFill>
+                <a:latin typeface="Arial"/>
+                <a:ea typeface="Arial"/>
+                <a:cs typeface="Arial"/>
+              </a:defRPr>
+            </a:pPr>
+            <a:r>
+              <a:rPr sz="1500" b="0">
+                <a:solidFill>
+                  <a:srgbClr val="53606D"/>
+                </a:solidFill>
+                <a:latin typeface="Arial"/>
+                <a:ea typeface="Arial"/>
+                <a:cs typeface="Arial"/>
+              </a:rPr>
+              <a:t>fora do histórico</a:t>
+            </a:r>
+          </a:p>
+          <a:p xmlns:a="http://schemas.openxmlformats.org/drawingml/2006/main">
+            <a:pPr algn="l">
+              <a:buNone/>
+              <a:defRPr sz="1500" b="0">
+                <a:solidFill>
+                  <a:srgbClr val="53606D"/>
+                </a:solidFill>
+                <a:latin typeface="Arial"/>
+                <a:ea typeface="Arial"/>
+                <a:cs typeface="Arial"/>
+              </a:defRPr>
+            </a:pPr>
+            <a:r>
+              <a:rPr sz="1500" b="0">
+                <a:solidFill>
+                  <a:srgbClr val="53606D"/>
+                </a:solidFill>
+                <a:latin typeface="Arial"/>
+                <a:ea typeface="Arial"/>
+                <a:cs typeface="Arial"/>
+              </a:rPr>
+              <a:t>recusadas</a:t>
+            </a:r>
+          </a:p>
+        </p:txBody>
+      </p:sp>
+      <p:pic>
+        <p:nvPicPr>
+          <p:cNvPr id="88" name=""/>
+          <p:cNvPicPr>
+            <a:picLocks xmlns:a="http://schemas.openxmlformats.org/drawingml/2006/main" noChangeAspect="1"/>
+          </p:cNvPicPr>
+          <p:nvPr/>
+        </p:nvPicPr>
+        <p:blipFill>
+          <a:blip xmlns:r="http://schemas.openxmlformats.org/officeDocument/2006/relationships" xmlns:a="http://schemas.openxmlformats.org/drawingml/2006/main" r:embed="Rc76b6684795640e2"/>
+          <a:srcRect xmlns:a="http://schemas.openxmlformats.org/drawingml/2006/main" l="0" t="10114" r="0" b="10114"/>
+          <a:stretch xmlns:a="http://schemas.openxmlformats.org/drawingml/2006/main">
+            <a:fillRect l="0" t="0" r="0" b="0"/>
+          </a:stretch>
+        </p:blipFill>
+        <p:spPr>
+          <a:xfrm xmlns:a="http://schemas.openxmlformats.org/drawingml/2006/main">
+            <a:off x="685800" y="5219700"/>
+            <a:ext cx="8915400" cy="5334000"/>
+          </a:xfrm>
+          <a:prstGeom xmlns:a="http://schemas.openxmlformats.org/drawingml/2006/main" prst="roundRect">
+            <a:avLst>
+              <a:gd name="adj" fmla="val 2143"/>
+            </a:avLst>
+          </a:prstGeom>
+        </p:spPr>
+      </p:pic>
+      <p:sp>
+        <p:nvSpPr>
+          <p:cNvPr id="13" name="scenario-close">
+            <a:extLst xmlns:a="http://schemas.openxmlformats.org/drawingml/2006/main">
+              <a:ext uri="{FF2B5EF4-FFF2-40B4-BE49-F238E27FC236}">
+                <a16:creationId xmlns:a16="http://schemas.microsoft.com/office/drawing/2014/main" id="{77D68B23-F225-4FB9-AD55-5D8FE63700B5}"/>
+              </a:ext>
+            </a:extLst>
+          </p:cNvPr>
+          <p:cNvSpPr>
+            <a:spLocks xmlns:a="http://schemas.openxmlformats.org/drawingml/2006/main" noGrp="1"/>
+          </p:cNvSpPr>
+          <p:nvPr/>
+        </p:nvSpPr>
+        <p:spPr>
+          <a:xfrm xmlns:a="http://schemas.openxmlformats.org/drawingml/2006/main">
+            <a:off x="685800" y="10953750"/>
+            <a:ext cx="8915400" cy="609600"/>
+          </a:xfrm>
+          <a:prstGeom xmlns:a="http://schemas.openxmlformats.org/drawingml/2006/main" prst="rect">
+            <a:avLst/>
+          </a:prstGeom>
+          <a:noFill xmlns:a="http://schemas.openxmlformats.org/drawingml/2006/main"/>
+          <a:ln xmlns:a="http://schemas.openxmlformats.org/drawingml/2006/main" w="0">
+            <a:noFill/>
+            <a:prstDash val="solid"/>
+          </a:ln>
+        </p:spPr>
+        <p:txBody>
+          <a:bodyPr xmlns:a="http://schemas.openxmlformats.org/drawingml/2006/main" anchor="t">
+            <a:normAutofit fontScale="100000"/>
+          </a:bodyPr>
+          <a:lstStyle xmlns:a="http://schemas.openxmlformats.org/drawingml/2006/main"/>
+          <a:p xmlns:a="http://schemas.openxmlformats.org/drawingml/2006/main">
+            <a:pPr algn="l">
+              <a:buNone/>
+              <a:defRPr sz="1875" b="1">
+                <a:solidFill>
+                  <a:srgbClr val="07111C"/>
+                </a:solidFill>
+                <a:latin typeface="Arial"/>
+                <a:ea typeface="Arial"/>
+                <a:cs typeface="Arial"/>
+              </a:defRPr>
+            </a:pPr>
+            <a:r>
+              <a:rPr sz="1875" b="1">
+                <a:solidFill>
+                  <a:srgbClr val="07111C"/>
+                </a:solidFill>
+                <a:latin typeface="Arial"/>
+                <a:ea typeface="Arial"/>
+                <a:cs typeface="Arial"/>
+              </a:rPr>
+              <a:t>Probabilidades + P10/P50/P90 + decisão humana.</a:t>
+            </a:r>
+          </a:p>
+        </p:txBody>
+      </p:sp>
+      <p:cxnSp>
+        <p:nvCxnSpPr>
+          <p:cNvPr id="90" name="footer-rule-7"/>
+          <p:cNvCxnSpPr/>
+          <p:nvPr/>
+        </p:nvCxnSpPr>
+        <p:spPr>
+          <a:xfrm xmlns:a="http://schemas.openxmlformats.org/drawingml/2006/main">
+            <a:off x="685800" y="12039600"/>
+            <a:ext cx="8915400" cy="0"/>
+          </a:xfrm>
+          <a:prstGeom xmlns:a="http://schemas.openxmlformats.org/drawingml/2006/main" prst="straightConnector1">
+            <a:avLst/>
+          </a:prstGeom>
+          <a:ln xmlns:a="http://schemas.openxmlformats.org/drawingml/2006/main" w="9525">
+            <a:solidFill>
+              <a:srgbClr val="BCC4CC"/>
+            </a:solidFill>
+            <a:prstDash val="solid"/>
+          </a:ln>
+        </p:spPr>
+      </p:cxnSp>
+      <p:sp>
+        <p:nvSpPr>
+          <p:cNvPr id="15" name="footer-7">
+            <a:extLst xmlns:a="http://schemas.openxmlformats.org/drawingml/2006/main">
+              <a:ext uri="{FF2B5EF4-FFF2-40B4-BE49-F238E27FC236}">
+                <a16:creationId xmlns:a16="http://schemas.microsoft.com/office/drawing/2014/main" id="{879FB160-5E7C-4A0A-BE16-8BA8440858BF}"/>
+              </a:ext>
+            </a:extLst>
+          </p:cNvPr>
+          <p:cNvSpPr>
+            <a:spLocks xmlns:a="http://schemas.openxmlformats.org/drawingml/2006/main" noGrp="1"/>
+          </p:cNvSpPr>
+          <p:nvPr/>
+        </p:nvSpPr>
+        <p:spPr>
+          <a:xfrm xmlns:a="http://schemas.openxmlformats.org/drawingml/2006/main">
+            <a:off x="685800" y="12211050"/>
+            <a:ext cx="7429500" cy="266700"/>
+          </a:xfrm>
+          <a:prstGeom xmlns:a="http://schemas.openxmlformats.org/drawingml/2006/main" prst="rect">
+            <a:avLst/>
+          </a:prstGeom>
+          <a:noFill xmlns:a="http://schemas.openxmlformats.org/drawingml/2006/main"/>
+          <a:ln xmlns:a="http://schemas.openxmlformats.org/drawingml/2006/main" w="0">
+            <a:noFill/>
+            <a:prstDash val="solid"/>
+          </a:ln>
+        </p:spPr>
+        <p:txBody>
+          <a:bodyPr xmlns:a="http://schemas.openxmlformats.org/drawingml/2006/main" anchor="t">
+            <a:normAutofit fontScale="95833"/>
+          </a:bodyPr>
+          <a:lstStyle xmlns:a="http://schemas.openxmlformats.org/drawingml/2006/main"/>
+          <a:p xmlns:a="http://schemas.openxmlformats.org/drawingml/2006/main">
+            <a:pPr algn="l">
+              <a:buNone/>
+              <a:defRPr sz="1200" b="0">
+                <a:solidFill>
+                  <a:srgbClr val="53606D"/>
+                </a:solidFill>
+                <a:latin typeface="Arial"/>
+                <a:ea typeface="Arial"/>
+                <a:cs typeface="Arial"/>
+              </a:defRPr>
+            </a:pPr>
+            <a:r>
+              <a:rPr sz="1200" b="0">
+                <a:solidFill>
+                  <a:srgbClr val="53606D"/>
+                </a:solidFill>
+                <a:latin typeface="Arial"/>
+                <a:ea typeface="Arial"/>
+                <a:cs typeface="Arial"/>
+              </a:rPr>
+              <a:t>100% sintético · sem controle de máquina</a:t>
+            </a:r>
+          </a:p>
+        </p:txBody>
+      </p:sp>
+      <p:sp>
+        <p:nvSpPr>
+          <p:cNvPr id="16" name="footer-page-7">
+            <a:extLst xmlns:a="http://schemas.openxmlformats.org/drawingml/2006/main">
+              <a:ext uri="{FF2B5EF4-FFF2-40B4-BE49-F238E27FC236}">
+                <a16:creationId xmlns:a16="http://schemas.microsoft.com/office/drawing/2014/main" id="{6CA91ED8-7E0E-433D-9AFA-55771DA22B52}"/>
+              </a:ext>
+            </a:extLst>
+          </p:cNvPr>
+          <p:cNvSpPr>
+            <a:spLocks xmlns:a="http://schemas.openxmlformats.org/drawingml/2006/main" noGrp="1"/>
+          </p:cNvSpPr>
+          <p:nvPr/>
+        </p:nvSpPr>
+        <p:spPr>
+          <a:xfrm xmlns:a="http://schemas.openxmlformats.org/drawingml/2006/main">
+            <a:off x="8763000" y="12211050"/>
+            <a:ext cx="838200" cy="266700"/>
+          </a:xfrm>
+          <a:prstGeom xmlns:a="http://schemas.openxmlformats.org/drawingml/2006/main" prst="rect">
+            <a:avLst/>
+          </a:prstGeom>
+          <a:noFill xmlns:a="http://schemas.openxmlformats.org/drawingml/2006/main"/>
+          <a:ln xmlns:a="http://schemas.openxmlformats.org/drawingml/2006/main" w="0">
+            <a:noFill/>
+            <a:prstDash val="solid"/>
+          </a:ln>
+        </p:spPr>
+        <p:txBody>
+          <a:bodyPr xmlns:a="http://schemas.openxmlformats.org/drawingml/2006/main" anchor="t">
+            <a:normAutofit fontScale="95833"/>
+          </a:bodyPr>
+          <a:lstStyle xmlns:a="http://schemas.openxmlformats.org/drawingml/2006/main"/>
+          <a:p xmlns:a="http://schemas.openxmlformats.org/drawingml/2006/main">
+            <a:pPr algn="r">
+              <a:buNone/>
+              <a:defRPr sz="1200" b="0">
+                <a:solidFill>
+                  <a:srgbClr val="53606D"/>
+                </a:solidFill>
+                <a:latin typeface="Arial"/>
+                <a:ea typeface="Arial"/>
+                <a:cs typeface="Arial"/>
+              </a:defRPr>
+            </a:pPr>
+            <a:r>
+              <a:rPr sz="1200" b="0">
+                <a:solidFill>
+                  <a:srgbClr val="53606D"/>
+                </a:solidFill>
+                <a:latin typeface="Arial"/>
+                <a:ea typeface="Arial"/>
+                <a:cs typeface="Arial"/>
+              </a:rPr>
+              <a:t>4/5</a:t>
+            </a:r>
+          </a:p>
+        </p:txBody>
+      </p:sp>
+    </p:spTree>
+    <p:extLst>
+      <p:ext uri="{BB962C8B-B14F-4D97-AF65-F5344CB8AC3E}">
+        <p14:creationId xmlns:p14="http://schemas.microsoft.com/office/powerpoint/2010/main" val="679812029"/>
+      </p:ext>
+    </p:extLst>
+  </p:cSld>
+</p:sld>
+</file>
+
+<file path=ppt/slides/slide5.xml><?xml version="1.0" encoding="utf-8"?>
+<p:sld xmlns:p="http://schemas.openxmlformats.org/presentationml/2006/main">
+  <p:cSld>
+    <p:bg>
+      <p:bgPr>
+        <a:solidFill xmlns:a="http://schemas.openxmlformats.org/drawingml/2006/main">
+          <a:srgbClr val="FFFFFF"/>
+        </a:solidFill>
+      </p:bgPr>
+    </p:bg>
+    <p:spTree>
+      <p:nvGrpSpPr>
+        <p:cNvPr id="1" name=""/>
+        <p:cNvGrpSpPr/>
+        <p:nvPr/>
+      </p:nvGrpSpPr>
+      <p:grpSpPr>
+        <a:xfrm xmlns:a="http://schemas.openxmlformats.org/drawingml/2006/main"/>
+      </p:grpSpPr>
+      <p:sp>
+        <p:nvSpPr>
+          <p:cNvPr id="10" name="close-kicker">
+            <a:extLst xmlns:a="http://schemas.openxmlformats.org/drawingml/2006/main">
+              <a:ext uri="{FF2B5EF4-FFF2-40B4-BE49-F238E27FC236}">
+                <a16:creationId xmlns:a16="http://schemas.microsoft.com/office/drawing/2014/main" id="{4A29BF44-3BDA-4C78-9CBD-C6046E39C2F2}"/>
+              </a:ext>
+            </a:extLst>
+          </p:cNvPr>
+          <p:cNvSpPr>
+            <a:spLocks xmlns:a="http://schemas.openxmlformats.org/drawingml/2006/main" noGrp="1"/>
+          </p:cNvSpPr>
+          <p:nvPr/>
+        </p:nvSpPr>
+        <p:spPr>
+          <a:xfrm xmlns:a="http://schemas.openxmlformats.org/drawingml/2006/main">
+            <a:off x="685800" y="762000"/>
+            <a:ext cx="8915400" cy="381000"/>
+          </a:xfrm>
+          <a:prstGeom xmlns:a="http://schemas.openxmlformats.org/drawingml/2006/main" prst="rect">
+            <a:avLst/>
+          </a:prstGeom>
+          <a:noFill xmlns:a="http://schemas.openxmlformats.org/drawingml/2006/main"/>
+          <a:ln xmlns:a="http://schemas.openxmlformats.org/drawingml/2006/main" w="0">
+            <a:noFill/>
+            <a:prstDash val="solid"/>
+          </a:ln>
+        </p:spPr>
+        <p:txBody>
+          <a:bodyPr xmlns:a="http://schemas.openxmlformats.org/drawingml/2006/main" anchor="t">
+            <a:normAutofit fontScale="100000"/>
+          </a:bodyPr>
+          <a:lstStyle xmlns:a="http://schemas.openxmlformats.org/drawingml/2006/main"/>
+          <a:p xmlns:a="http://schemas.openxmlformats.org/drawingml/2006/main">
+            <a:pPr algn="l">
+              <a:buNone/>
+              <a:defRPr sz="1425" b="1">
+                <a:solidFill>
+                  <a:srgbClr val="3D8DFF"/>
+                </a:solidFill>
+                <a:latin typeface="Arial"/>
+                <a:ea typeface="Arial"/>
+                <a:cs typeface="Arial"/>
+              </a:defRPr>
+            </a:pPr>
+            <a:r>
+              <a:rPr sz="1425" b="1">
+                <a:solidFill>
+                  <a:srgbClr val="3D8DFF"/>
+                </a:solidFill>
+                <a:latin typeface="Arial"/>
+                <a:ea typeface="Arial"/>
+                <a:cs typeface="Arial"/>
+              </a:rPr>
+              <a:t>STEELFLOW AI</a:t>
+            </a:r>
+          </a:p>
+        </p:txBody>
+      </p:sp>
+      <p:sp>
+        <p:nvSpPr>
+          <p:cNvPr id="2" name="close-title">
+            <a:extLst xmlns:a="http://schemas.openxmlformats.org/drawingml/2006/main">
+              <a:ext uri="{FF2B5EF4-FFF2-40B4-BE49-F238E27FC236}">
+                <a16:creationId xmlns:a16="http://schemas.microsoft.com/office/drawing/2014/main" id="{584C9D75-4C20-4B03-ABCF-158C3E284423}"/>
+              </a:ext>
+            </a:extLst>
+          </p:cNvPr>
+          <p:cNvSpPr>
+            <a:spLocks xmlns:a="http://schemas.openxmlformats.org/drawingml/2006/main" noGrp="1"/>
+          </p:cNvSpPr>
+          <p:nvPr/>
+        </p:nvSpPr>
+        <p:spPr>
+          <a:xfrm xmlns:a="http://schemas.openxmlformats.org/drawingml/2006/main">
+            <a:off x="685800" y="1762125"/>
+            <a:ext cx="8915400" cy="2095500"/>
+          </a:xfrm>
+          <a:prstGeom xmlns:a="http://schemas.openxmlformats.org/drawingml/2006/main" prst="rect">
+            <a:avLst/>
+          </a:prstGeom>
+          <a:noFill xmlns:a="http://schemas.openxmlformats.org/drawingml/2006/main"/>
+          <a:ln xmlns:a="http://schemas.openxmlformats.org/drawingml/2006/main" w="0">
+            <a:noFill/>
+            <a:prstDash val="solid"/>
+          </a:ln>
+        </p:spPr>
+        <p:txBody>
+          <a:bodyPr xmlns:a="http://schemas.openxmlformats.org/drawingml/2006/main" anchor="t">
+            <a:normAutofit fontScale="100000"/>
+          </a:bodyPr>
+          <a:lstStyle xmlns:a="http://schemas.openxmlformats.org/drawingml/2006/main"/>
+          <a:p xmlns:a="http://schemas.openxmlformats.org/drawingml/2006/main">
+            <a:pPr algn="l">
+              <a:buNone/>
+              <a:defRPr sz="4950" b="1">
+                <a:solidFill>
+                  <a:srgbClr val="07111C"/>
+                </a:solidFill>
+                <a:latin typeface="Arial"/>
+                <a:ea typeface="Arial"/>
+                <a:cs typeface="Arial"/>
+              </a:defRPr>
+            </a:pPr>
+            <a:r>
+              <a:rPr sz="4950" b="1">
+                <a:solidFill>
+                  <a:srgbClr val="07111C"/>
+                </a:solidFill>
+                <a:latin typeface="Arial"/>
+                <a:ea typeface="Arial"/>
+                <a:cs typeface="Arial"/>
+              </a:rPr>
+              <a:t>Explore a</a:t>
+            </a:r>
+          </a:p>
+          <a:p xmlns:a="http://schemas.openxmlformats.org/drawingml/2006/main">
+            <a:pPr algn="l">
+              <a:buNone/>
+              <a:defRPr sz="4950" b="1">
+                <a:solidFill>
+                  <a:srgbClr val="07111C"/>
+                </a:solidFill>
+                <a:latin typeface="Arial"/>
+                <a:ea typeface="Arial"/>
+                <a:cs typeface="Arial"/>
+              </a:defRPr>
+            </a:pPr>
+            <a:r>
+              <a:rPr sz="4950" b="1">
+                <a:solidFill>
+                  <a:srgbClr val="07111C"/>
+                </a:solidFill>
+                <a:latin typeface="Arial"/>
+                <a:ea typeface="Arial"/>
+                <a:cs typeface="Arial"/>
+              </a:rPr>
+              <a:t>plataforma.</a:t>
+            </a:r>
+          </a:p>
+        </p:txBody>
+      </p:sp>
+      <p:sp>
+        <p:nvSpPr>
+          <p:cNvPr id="3" name="close-body">
+            <a:extLst xmlns:a="http://schemas.openxmlformats.org/drawingml/2006/main">
+              <a:ext uri="{FF2B5EF4-FFF2-40B4-BE49-F238E27FC236}">
+                <a16:creationId xmlns:a16="http://schemas.microsoft.com/office/drawing/2014/main" id="{B4D2B44C-B7F8-4096-840E-D7E4AEEFC94C}"/>
+              </a:ext>
+            </a:extLst>
+          </p:cNvPr>
+          <p:cNvSpPr>
+            <a:spLocks xmlns:a="http://schemas.openxmlformats.org/drawingml/2006/main" noGrp="1"/>
+          </p:cNvSpPr>
+          <p:nvPr/>
+        </p:nvSpPr>
+        <p:spPr>
+          <a:xfrm xmlns:a="http://schemas.openxmlformats.org/drawingml/2006/main">
+            <a:off x="685800" y="4476750"/>
+            <a:ext cx="8191500" cy="1428750"/>
+          </a:xfrm>
+          <a:prstGeom xmlns:a="http://schemas.openxmlformats.org/drawingml/2006/main" prst="rect">
+            <a:avLst/>
+          </a:prstGeom>
+          <a:noFill xmlns:a="http://schemas.openxmlformats.org/drawingml/2006/main"/>
+          <a:ln xmlns:a="http://schemas.openxmlformats.org/drawingml/2006/main" w="0">
+            <a:noFill/>
+            <a:prstDash val="solid"/>
+          </a:ln>
+        </p:spPr>
+        <p:txBody>
+          <a:bodyPr xmlns:a="http://schemas.openxmlformats.org/drawingml/2006/main" anchor="t">
+            <a:normAutofit fontScale="100000"/>
+          </a:bodyPr>
+          <a:lstStyle xmlns:a="http://schemas.openxmlformats.org/drawingml/2006/main"/>
+          <a:p xmlns:a="http://schemas.openxmlformats.org/drawingml/2006/main">
+            <a:pPr algn="l">
+              <a:buNone/>
               <a:defRPr sz="2175" b="0">
                 <a:solidFill>
                   <a:srgbClr val="53606D"/>
@@ -2769,7 +5059,7 @@
                 <a:ea typeface="Arial"/>
                 <a:cs typeface="Arial"/>
               </a:rPr>
-              <a:t>O sistema não substitui o especialista. Ele organiza evidências para comparar cenários antes de agir.</a:t>
+              <a:t>Veja as telas, teste o fluxo e questione os limites.</a:t>
             </a:r>
           </a:p>
         </p:txBody>
@@ -2968,7 +5258,7 @@
                 <a:ea typeface="Arial"/>
                 <a:cs typeface="Arial"/>
               </a:rPr>
-              <a:t>Que parâmetro você testaria primeiro se pudesse comparar o resultado antes do ajuste?</a:t>
+              <a:t>Qual hipótese você testaria primeiro?</a:t>
             </a:r>
           </a:p>
         </p:txBody>
@@ -3086,7 +5376,7 @@
                 <a:ea typeface="Arial"/>
                 <a:cs typeface="Arial"/>
               </a:rPr>
-              <a:t>3/3</a:t>
+              <a:t>5/5</a:t>
             </a:r>
           </a:p>
         </p:txBody>

</xml_diff>